<commit_message>
Voortgangsdeck: de geverifieerde stap ook als endpoint en bericht
Na de voorbeelduitwerking volgt nu een slide die dezelfde stap toont zoals die
in de koppelvlakspecificatie landt: het endpoint op het planningssysteem, de
interactie in drie regels (planning meldt, catalogus haalt op, planning levert)
en een ingekort voorbeeldbericht uit de datamodelschema's. Daarmee ziet de zaal
waar de route op uitkomt. Toetsen heet nu verifieren, op de slide en op de
kaart erbij.

De woordenteller houdt code buiten het woordbudget en meldt in plaats daarvan
het aantal coderegels, met een grens van twaalf; skill en README leggen uit
waarom een bericht een drager is en geen leestekst.

Co-Authored-By: Claude Opus 5 <noreply@anthropic.com>
Claude-Session: https://claude.ai/code/session_01U2MjeqKoEDeZ8DcuBYKUcY
</commit_message>
<xml_diff>
--- a/presentaties/export/260929_werkgroep_okx_voortgang/260929_werkgroep_okx_voortgang.pptx
+++ b/presentaties/export/260929_werkgroep_okx_voortgang/260929_werkgroep_okx_voortgang.pptx
@@ -11,6 +11,7 @@
     <p:sldId id="259" r:id="rId6"/>
     <p:sldId id="260" r:id="rId7"/>
     <p:sldId id="261" r:id="rId8"/>
+    <p:sldId id="262" r:id="rId9"/>
   </p:sldIdLst>
   <p:sldSz cx="9336088" cy="5257800"/>
   <p:notesSz cx="7559675" cy="10691813"/>
@@ -16967,7 +16968,7 @@
         <p:spPr>
           <a:xfrm>
             <a:off x="439920" y="577080"/>
-            <a:ext cx="7038720" cy="399600"/>
+            <a:ext cx="7408800" cy="399600"/>
           </a:xfrm>
           <a:prstGeom prst="rect">
             <a:avLst/>
@@ -16990,7 +16991,7 @@
                 <a:latin typeface="Arial"/>
                 <a:ea typeface="Arial"/>
               </a:rPr>
-              <a:t>Toetsen met voorbeelduitwerkingen</a:t>
+              <a:t>Veriﬁëren met voorbeelduitwerkingen</a:t>
             </a:r>
             <a:endParaRPr b="0" lang="en-US" sz="2700" spc="-1" strike="noStrike">
               <a:solidFill>
@@ -18095,7 +18096,7 @@
         <p:spPr>
           <a:xfrm>
             <a:off x="4935600" y="3663720"/>
-            <a:ext cx="1308240" cy="160560"/>
+            <a:ext cx="1646640" cy="160560"/>
           </a:xfrm>
           <a:prstGeom prst="rect">
             <a:avLst/>
@@ -18118,7 +18119,7 @@
                 <a:latin typeface="Arial"/>
                 <a:ea typeface="Arial"/>
               </a:rPr>
-              <a:t>Toets bij scholen</a:t>
+              <a:t>Veriﬁëren bij scholen</a:t>
             </a:r>
             <a:endParaRPr b="0" lang="en-US" sz="1080" spc="-1" strike="noStrike">
               <a:solidFill>
@@ -18634,13 +18635,56 @@
       <p:sp>
         <p:nvSpPr>
           <p:cNvPr id="252" name=""/>
+          <p:cNvSpPr txBox="1"/>
+          <p:nvPr/>
+        </p:nvSpPr>
+        <p:spPr>
+          <a:xfrm>
+            <a:off x="439920" y="758160"/>
+            <a:ext cx="4424760" cy="399600"/>
+          </a:xfrm>
+          <a:prstGeom prst="rect">
+            <a:avLst/>
+          </a:prstGeom>
+          <a:noFill/>
+          <a:ln w="0">
+            <a:noFill/>
+          </a:ln>
+        </p:spPr>
+        <p:txBody>
+          <a:bodyPr lIns="0" rIns="0" tIns="0" bIns="0" anchor="t">
+            <a:noAutofit/>
+          </a:bodyPr>
+          <a:p>
+            <a:r>
+              <a:rPr b="1" lang="en-US" sz="2700" spc="-1" strike="noStrike">
+                <a:solidFill>
+                  <a:srgbClr val="dd784b"/>
+                </a:solidFill>
+                <a:latin typeface="Arial"/>
+                <a:ea typeface="Arial"/>
+              </a:rPr>
+              <a:t>Van beeld naar bericht</a:t>
+            </a:r>
+            <a:endParaRPr b="0" lang="en-US" sz="2700" spc="-1" strike="noStrike">
+              <a:solidFill>
+                <a:srgbClr val="000000"/>
+              </a:solidFill>
+              <a:latin typeface="DejaVu Serif"/>
+            </a:endParaRPr>
+          </a:p>
+        </p:txBody>
+      </p:sp>
+      <p:sp>
+        <p:nvSpPr>
+          <p:cNvPr id="253" name=""/>
           <p:cNvSpPr/>
           <p:nvPr/>
         </p:nvSpPr>
         <p:spPr>
           <a:xfrm>
-            <a:off x="456840" y="1609560"/>
-            <a:ext cx="4153320" cy="752760"/>
+            <a:off x="456840" y="1628640"/>
+            <a:ext cx="4124880" cy="1410120"/>
           </a:xfrm>
           <a:custGeom>
             <a:avLst/>
@@ -18648,18 +18692,18 @@
             <a:ahLst/>
             <a:rect l="0" t="0" r="r" b="b"/>
             <a:pathLst>
-              <a:path w="11537" h="2091">
-                <a:moveTo>
-                  <a:pt x="0" y="0"/>
-                </a:moveTo>
-                <a:lnTo>
-                  <a:pt x="11537" y="0"/>
-                </a:lnTo>
-                <a:lnTo>
-                  <a:pt x="11537" y="2091"/>
-                </a:lnTo>
-                <a:lnTo>
-                  <a:pt x="0" y="2091"/>
+              <a:path w="11458" h="3917">
+                <a:moveTo>
+                  <a:pt x="0" y="0"/>
+                </a:moveTo>
+                <a:lnTo>
+                  <a:pt x="11458" y="0"/>
+                </a:lnTo>
+                <a:lnTo>
+                  <a:pt x="11458" y="3917"/>
+                </a:lnTo>
+                <a:lnTo>
+                  <a:pt x="0" y="3917"/>
                 </a:lnTo>
                 <a:lnTo>
                   <a:pt x="0" y="0"/>
@@ -18691,14 +18735,14 @@
       </p:sp>
       <p:sp>
         <p:nvSpPr>
-          <p:cNvPr id="253" name=""/>
+          <p:cNvPr id="254" name=""/>
           <p:cNvSpPr/>
           <p:nvPr/>
         </p:nvSpPr>
         <p:spPr>
           <a:xfrm>
-            <a:off x="456840" y="1609560"/>
-            <a:ext cx="4153320" cy="38520"/>
+            <a:off x="456840" y="1628640"/>
+            <a:ext cx="4124880" cy="38520"/>
           </a:xfrm>
           <a:custGeom>
             <a:avLst/>
@@ -18706,15 +18750,305 @@
             <a:ahLst/>
             <a:rect l="0" t="0" r="r" b="b"/>
             <a:pathLst>
-              <a:path w="11537" h="107">
-                <a:moveTo>
-                  <a:pt x="0" y="0"/>
-                </a:moveTo>
-                <a:lnTo>
-                  <a:pt x="11537" y="0"/>
-                </a:lnTo>
-                <a:lnTo>
-                  <a:pt x="11537" y="107"/>
+              <a:path w="11458" h="107">
+                <a:moveTo>
+                  <a:pt x="0" y="0"/>
+                </a:moveTo>
+                <a:lnTo>
+                  <a:pt x="11458" y="0"/>
+                </a:lnTo>
+                <a:lnTo>
+                  <a:pt x="11458" y="107"/>
+                </a:lnTo>
+                <a:lnTo>
+                  <a:pt x="0" y="107"/>
+                </a:lnTo>
+                <a:lnTo>
+                  <a:pt x="0" y="0"/>
+                </a:lnTo>
+                <a:close/>
+              </a:path>
+            </a:pathLst>
+          </a:custGeom>
+          <a:solidFill>
+            <a:srgbClr val="3d68ec"/>
+          </a:solidFill>
+          <a:ln w="0">
+            <a:noFill/>
+          </a:ln>
+        </p:spPr>
+        <p:txBody>
+          <a:bodyPr lIns="0" rIns="0" tIns="0" bIns="0" anchor="t">
+            <a:noAutofit/>
+          </a:bodyPr>
+          <a:p>
+            <a:endParaRPr b="0" lang="en-US" sz="2400" spc="-1" strike="noStrike">
+              <a:solidFill>
+                <a:srgbClr val="000000"/>
+              </a:solidFill>
+              <a:latin typeface="DejaVu Serif"/>
+            </a:endParaRPr>
+          </a:p>
+        </p:txBody>
+      </p:sp>
+      <p:sp>
+        <p:nvSpPr>
+          <p:cNvPr id="255" name=""/>
+          <p:cNvSpPr/>
+          <p:nvPr/>
+        </p:nvSpPr>
+        <p:spPr>
+          <a:xfrm>
+            <a:off x="456840" y="3028680"/>
+            <a:ext cx="4124880" cy="10080"/>
+          </a:xfrm>
+          <a:custGeom>
+            <a:avLst/>
+            <a:gdLst/>
+            <a:ahLst/>
+            <a:rect l="0" t="0" r="r" b="b"/>
+            <a:pathLst>
+              <a:path w="11458" h="28">
+                <a:moveTo>
+                  <a:pt x="0" y="0"/>
+                </a:moveTo>
+                <a:lnTo>
+                  <a:pt x="11458" y="0"/>
+                </a:lnTo>
+                <a:lnTo>
+                  <a:pt x="11458" y="28"/>
+                </a:lnTo>
+                <a:lnTo>
+                  <a:pt x="0" y="28"/>
+                </a:lnTo>
+                <a:lnTo>
+                  <a:pt x="0" y="0"/>
+                </a:lnTo>
+                <a:close/>
+              </a:path>
+            </a:pathLst>
+          </a:custGeom>
+          <a:solidFill>
+            <a:srgbClr val="e5e7eb"/>
+          </a:solidFill>
+          <a:ln w="0">
+            <a:noFill/>
+          </a:ln>
+        </p:spPr>
+        <p:txBody>
+          <a:bodyPr lIns="0" rIns="0" tIns="0" bIns="0" anchor="t">
+            <a:noAutofit/>
+          </a:bodyPr>
+          <a:p>
+            <a:endParaRPr b="0" lang="en-US" sz="2400" spc="-1" strike="noStrike">
+              <a:solidFill>
+                <a:srgbClr val="000000"/>
+              </a:solidFill>
+              <a:latin typeface="DejaVu Serif"/>
+            </a:endParaRPr>
+          </a:p>
+        </p:txBody>
+      </p:sp>
+      <p:sp>
+        <p:nvSpPr>
+          <p:cNvPr id="256" name=""/>
+          <p:cNvSpPr/>
+          <p:nvPr/>
+        </p:nvSpPr>
+        <p:spPr>
+          <a:xfrm>
+            <a:off x="4571640" y="1628640"/>
+            <a:ext cx="10080" cy="1410120"/>
+          </a:xfrm>
+          <a:custGeom>
+            <a:avLst/>
+            <a:gdLst/>
+            <a:ahLst/>
+            <a:rect l="0" t="0" r="r" b="b"/>
+            <a:pathLst>
+              <a:path w="28" h="3917">
+                <a:moveTo>
+                  <a:pt x="0" y="106"/>
+                </a:moveTo>
+                <a:lnTo>
+                  <a:pt x="0" y="3917"/>
+                </a:lnTo>
+                <a:lnTo>
+                  <a:pt x="28" y="3917"/>
+                </a:lnTo>
+                <a:lnTo>
+                  <a:pt x="28" y="0"/>
+                </a:lnTo>
+                <a:lnTo>
+                  <a:pt x="0" y="106"/>
+                </a:lnTo>
+                <a:close/>
+              </a:path>
+            </a:pathLst>
+          </a:custGeom>
+          <a:solidFill>
+            <a:srgbClr val="e5e7eb"/>
+          </a:solidFill>
+          <a:ln w="0">
+            <a:noFill/>
+          </a:ln>
+        </p:spPr>
+        <p:txBody>
+          <a:bodyPr lIns="0" rIns="0" tIns="0" bIns="0" anchor="t">
+            <a:noAutofit/>
+          </a:bodyPr>
+          <a:p>
+            <a:endParaRPr b="0" lang="en-US" sz="2400" spc="-1" strike="noStrike">
+              <a:solidFill>
+                <a:srgbClr val="000000"/>
+              </a:solidFill>
+              <a:latin typeface="DejaVu Serif"/>
+            </a:endParaRPr>
+          </a:p>
+        </p:txBody>
+      </p:sp>
+      <p:sp>
+        <p:nvSpPr>
+          <p:cNvPr id="257" name=""/>
+          <p:cNvSpPr/>
+          <p:nvPr/>
+        </p:nvSpPr>
+        <p:spPr>
+          <a:xfrm>
+            <a:off x="456840" y="1628640"/>
+            <a:ext cx="10080" cy="1410120"/>
+          </a:xfrm>
+          <a:custGeom>
+            <a:avLst/>
+            <a:gdLst/>
+            <a:ahLst/>
+            <a:rect l="0" t="0" r="r" b="b"/>
+            <a:pathLst>
+              <a:path w="28" h="3917">
+                <a:moveTo>
+                  <a:pt x="0" y="0"/>
+                </a:moveTo>
+                <a:lnTo>
+                  <a:pt x="0" y="3917"/>
+                </a:lnTo>
+                <a:lnTo>
+                  <a:pt x="28" y="3917"/>
+                </a:lnTo>
+                <a:lnTo>
+                  <a:pt x="28" y="106"/>
+                </a:lnTo>
+                <a:lnTo>
+                  <a:pt x="0" y="0"/>
+                </a:lnTo>
+                <a:close/>
+              </a:path>
+            </a:pathLst>
+          </a:custGeom>
+          <a:solidFill>
+            <a:srgbClr val="e5e7eb"/>
+          </a:solidFill>
+          <a:ln w="0">
+            <a:noFill/>
+          </a:ln>
+        </p:spPr>
+        <p:txBody>
+          <a:bodyPr lIns="0" rIns="0" tIns="0" bIns="0" anchor="t">
+            <a:noAutofit/>
+          </a:bodyPr>
+          <a:p>
+            <a:endParaRPr b="0" lang="en-US" sz="2400" spc="-1" strike="noStrike">
+              <a:solidFill>
+                <a:srgbClr val="000000"/>
+              </a:solidFill>
+              <a:latin typeface="DejaVu Serif"/>
+            </a:endParaRPr>
+          </a:p>
+        </p:txBody>
+      </p:sp>
+      <p:sp>
+        <p:nvSpPr>
+          <p:cNvPr id="258" name=""/>
+          <p:cNvSpPr/>
+          <p:nvPr/>
+        </p:nvSpPr>
+        <p:spPr>
+          <a:xfrm>
+            <a:off x="456840" y="3152520"/>
+            <a:ext cx="4124880" cy="1019520"/>
+          </a:xfrm>
+          <a:custGeom>
+            <a:avLst/>
+            <a:gdLst/>
+            <a:ahLst/>
+            <a:rect l="0" t="0" r="r" b="b"/>
+            <a:pathLst>
+              <a:path w="11458" h="2832">
+                <a:moveTo>
+                  <a:pt x="0" y="0"/>
+                </a:moveTo>
+                <a:lnTo>
+                  <a:pt x="11458" y="0"/>
+                </a:lnTo>
+                <a:lnTo>
+                  <a:pt x="11458" y="2832"/>
+                </a:lnTo>
+                <a:lnTo>
+                  <a:pt x="0" y="2832"/>
+                </a:lnTo>
+                <a:lnTo>
+                  <a:pt x="0" y="0"/>
+                </a:lnTo>
+                <a:close/>
+              </a:path>
+            </a:pathLst>
+          </a:custGeom>
+          <a:solidFill>
+            <a:srgbClr val="ffffff"/>
+          </a:solidFill>
+          <a:ln w="0">
+            <a:noFill/>
+          </a:ln>
+        </p:spPr>
+        <p:txBody>
+          <a:bodyPr lIns="0" rIns="0" tIns="0" bIns="0" anchor="t">
+            <a:noAutofit/>
+          </a:bodyPr>
+          <a:p>
+            <a:endParaRPr b="0" lang="en-US" sz="2400" spc="-1" strike="noStrike">
+              <a:solidFill>
+                <a:srgbClr val="000000"/>
+              </a:solidFill>
+              <a:latin typeface="DejaVu Serif"/>
+            </a:endParaRPr>
+          </a:p>
+        </p:txBody>
+      </p:sp>
+      <p:sp>
+        <p:nvSpPr>
+          <p:cNvPr id="259" name=""/>
+          <p:cNvSpPr/>
+          <p:nvPr/>
+        </p:nvSpPr>
+        <p:spPr>
+          <a:xfrm>
+            <a:off x="456840" y="3152520"/>
+            <a:ext cx="4124880" cy="38520"/>
+          </a:xfrm>
+          <a:custGeom>
+            <a:avLst/>
+            <a:gdLst/>
+            <a:ahLst/>
+            <a:rect l="0" t="0" r="r" b="b"/>
+            <a:pathLst>
+              <a:path w="11458" h="107">
+                <a:moveTo>
+                  <a:pt x="0" y="0"/>
+                </a:moveTo>
+                <a:lnTo>
+                  <a:pt x="11458" y="0"/>
+                </a:lnTo>
+                <a:lnTo>
+                  <a:pt x="11458" y="107"/>
                 </a:lnTo>
                 <a:lnTo>
                   <a:pt x="0" y="107"/>
@@ -18749,14 +19083,14 @@
       </p:sp>
       <p:sp>
         <p:nvSpPr>
-          <p:cNvPr id="254" name=""/>
+          <p:cNvPr id="260" name=""/>
           <p:cNvSpPr/>
           <p:nvPr/>
         </p:nvSpPr>
         <p:spPr>
           <a:xfrm>
-            <a:off x="456840" y="2352600"/>
-            <a:ext cx="4153320" cy="9720"/>
+            <a:off x="456840" y="4162320"/>
+            <a:ext cx="4124880" cy="9720"/>
           </a:xfrm>
           <a:custGeom>
             <a:avLst/>
@@ -18764,15 +19098,15 @@
             <a:ahLst/>
             <a:rect l="0" t="0" r="r" b="b"/>
             <a:pathLst>
-              <a:path w="11537" h="27">
-                <a:moveTo>
-                  <a:pt x="0" y="0"/>
-                </a:moveTo>
-                <a:lnTo>
-                  <a:pt x="11537" y="0"/>
-                </a:lnTo>
-                <a:lnTo>
-                  <a:pt x="11537" y="27"/>
+              <a:path w="11458" h="27">
+                <a:moveTo>
+                  <a:pt x="0" y="0"/>
+                </a:moveTo>
+                <a:lnTo>
+                  <a:pt x="11458" y="0"/>
+                </a:lnTo>
+                <a:lnTo>
+                  <a:pt x="11458" y="27"/>
                 </a:lnTo>
                 <a:lnTo>
                   <a:pt x="0" y="27"/>
@@ -18807,14 +19141,14 @@
       </p:sp>
       <p:sp>
         <p:nvSpPr>
-          <p:cNvPr id="255" name=""/>
+          <p:cNvPr id="261" name=""/>
           <p:cNvSpPr/>
           <p:nvPr/>
         </p:nvSpPr>
         <p:spPr>
           <a:xfrm>
-            <a:off x="4600440" y="1609560"/>
-            <a:ext cx="9720" cy="752760"/>
+            <a:off x="4571640" y="3152520"/>
+            <a:ext cx="10080" cy="1019520"/>
           </a:xfrm>
           <a:custGeom>
             <a:avLst/>
@@ -18822,18 +19156,18 @@
             <a:ahLst/>
             <a:rect l="0" t="0" r="r" b="b"/>
             <a:pathLst>
-              <a:path w="27" h="2091">
+              <a:path w="28" h="2832">
                 <a:moveTo>
                   <a:pt x="0" y="106"/>
                 </a:moveTo>
                 <a:lnTo>
-                  <a:pt x="0" y="2091"/>
-                </a:lnTo>
-                <a:lnTo>
-                  <a:pt x="27" y="2091"/>
-                </a:lnTo>
-                <a:lnTo>
-                  <a:pt x="27" y="0"/>
+                  <a:pt x="0" y="2832"/>
+                </a:lnTo>
+                <a:lnTo>
+                  <a:pt x="28" y="2832"/>
+                </a:lnTo>
+                <a:lnTo>
+                  <a:pt x="28" y="0"/>
                 </a:lnTo>
                 <a:lnTo>
                   <a:pt x="0" y="106"/>
@@ -18865,14 +19199,14 @@
       </p:sp>
       <p:sp>
         <p:nvSpPr>
-          <p:cNvPr id="256" name=""/>
+          <p:cNvPr id="262" name=""/>
           <p:cNvSpPr/>
           <p:nvPr/>
         </p:nvSpPr>
         <p:spPr>
           <a:xfrm>
-            <a:off x="456840" y="1609560"/>
-            <a:ext cx="10080" cy="752760"/>
+            <a:off x="456840" y="3152520"/>
+            <a:ext cx="10080" cy="1019520"/>
           </a:xfrm>
           <a:custGeom>
             <a:avLst/>
@@ -18880,15 +19214,15 @@
             <a:ahLst/>
             <a:rect l="0" t="0" r="r" b="b"/>
             <a:pathLst>
-              <a:path w="28" h="2091">
-                <a:moveTo>
-                  <a:pt x="0" y="0"/>
-                </a:moveTo>
-                <a:lnTo>
-                  <a:pt x="0" y="2091"/>
-                </a:lnTo>
-                <a:lnTo>
-                  <a:pt x="28" y="2091"/>
+              <a:path w="28" h="2832">
+                <a:moveTo>
+                  <a:pt x="0" y="0"/>
+                </a:moveTo>
+                <a:lnTo>
+                  <a:pt x="0" y="2832"/>
+                </a:lnTo>
+                <a:lnTo>
+                  <a:pt x="28" y="2832"/>
                 </a:lnTo>
                 <a:lnTo>
                   <a:pt x="28" y="106"/>
@@ -18923,7 +19257,2843 @@
       </p:sp>
       <p:sp>
         <p:nvSpPr>
-          <p:cNvPr id="257" name=""/>
+          <p:cNvPr id="263" name=""/>
+          <p:cNvSpPr txBox="1"/>
+          <p:nvPr/>
+        </p:nvSpPr>
+        <p:spPr>
+          <a:xfrm>
+            <a:off x="457200" y="1356120"/>
+            <a:ext cx="1832400" cy="151200"/>
+          </a:xfrm>
+          <a:prstGeom prst="rect">
+            <a:avLst/>
+          </a:prstGeom>
+          <a:noFill/>
+          <a:ln w="0">
+            <a:noFill/>
+          </a:ln>
+        </p:spPr>
+        <p:txBody>
+          <a:bodyPr lIns="0" rIns="0" tIns="0" bIns="0" anchor="t">
+            <a:noAutofit/>
+          </a:bodyPr>
+          <a:p>
+            <a:r>
+              <a:rPr b="0" lang="en-US" sz="1020" spc="-1" strike="noStrike">
+                <a:solidFill>
+                  <a:srgbClr val="6b7280"/>
+                </a:solidFill>
+                <a:latin typeface="Arial"/>
+                <a:ea typeface="Arial"/>
+              </a:rPr>
+              <a:t>Dezelfde stap, als koppeling</a:t>
+            </a:r>
+            <a:endParaRPr b="0" lang="en-US" sz="1020" spc="-1" strike="noStrike">
+              <a:solidFill>
+                <a:srgbClr val="000000"/>
+              </a:solidFill>
+              <a:latin typeface="DejaVu Serif"/>
+            </a:endParaRPr>
+          </a:p>
+        </p:txBody>
+      </p:sp>
+      <p:sp>
+        <p:nvSpPr>
+          <p:cNvPr id="264" name=""/>
+          <p:cNvSpPr txBox="1"/>
+          <p:nvPr/>
+        </p:nvSpPr>
+        <p:spPr>
+          <a:xfrm>
+            <a:off x="603720" y="1793880"/>
+            <a:ext cx="770400" cy="163440"/>
+          </a:xfrm>
+          <a:prstGeom prst="rect">
+            <a:avLst/>
+          </a:prstGeom>
+          <a:noFill/>
+          <a:ln w="0">
+            <a:noFill/>
+          </a:ln>
+        </p:spPr>
+        <p:txBody>
+          <a:bodyPr lIns="0" rIns="0" tIns="0" bIns="0" anchor="t">
+            <a:noAutofit/>
+          </a:bodyPr>
+          <a:p>
+            <a:r>
+              <a:rPr b="1" lang="en-US" sz="1110" spc="-1" strike="noStrike">
+                <a:solidFill>
+                  <a:srgbClr val="1a1a2e"/>
+                </a:solidFill>
+                <a:latin typeface="Arial"/>
+                <a:ea typeface="Arial"/>
+              </a:rPr>
+              <a:t>Interactie</a:t>
+            </a:r>
+            <a:endParaRPr b="0" lang="en-US" sz="1110" spc="-1" strike="noStrike">
+              <a:solidFill>
+                <a:srgbClr val="000000"/>
+              </a:solidFill>
+              <a:latin typeface="DejaVu Serif"/>
+            </a:endParaRPr>
+          </a:p>
+        </p:txBody>
+      </p:sp>
+      <p:sp>
+        <p:nvSpPr>
+          <p:cNvPr id="265" name=""/>
+          <p:cNvSpPr txBox="1"/>
+          <p:nvPr/>
+        </p:nvSpPr>
+        <p:spPr>
+          <a:xfrm>
+            <a:off x="603720" y="2074680"/>
+            <a:ext cx="1509480" cy="145080"/>
+          </a:xfrm>
+          <a:prstGeom prst="rect">
+            <a:avLst/>
+          </a:prstGeom>
+          <a:noFill/>
+          <a:ln w="0">
+            <a:noFill/>
+          </a:ln>
+        </p:spPr>
+        <p:txBody>
+          <a:bodyPr lIns="0" rIns="0" tIns="0" bIns="0" anchor="t">
+            <a:noAutofit/>
+          </a:bodyPr>
+          <a:p>
+            <a:r>
+              <a:rPr b="1" lang="en-US" sz="980" spc="-1" strike="noStrike">
+                <a:solidFill>
+                  <a:srgbClr val="3d68ec"/>
+                </a:solidFill>
+                <a:latin typeface="Arial"/>
+                <a:ea typeface="Arial"/>
+              </a:rPr>
+              <a:t>Planning </a:t>
+            </a:r>
+            <a:r>
+              <a:rPr b="1" lang="en-US" sz="980" spc="-1" strike="noStrike">
+                <a:solidFill>
+                  <a:srgbClr val="3d68ec"/>
+                </a:solidFill>
+                <a:latin typeface="DejaVuSans"/>
+                <a:ea typeface="DejaVuSans"/>
+              </a:rPr>
+              <a:t>→ </a:t>
+            </a:r>
+            <a:r>
+              <a:rPr b="1" lang="en-US" sz="980" spc="-1" strike="noStrike">
+                <a:solidFill>
+                  <a:srgbClr val="3d68ec"/>
+                </a:solidFill>
+                <a:latin typeface="Arial"/>
+                <a:ea typeface="Arial"/>
+              </a:rPr>
+              <a:t>Catalogus</a:t>
+            </a:r>
+            <a:endParaRPr b="0" lang="en-US" sz="980" spc="-1" strike="noStrike">
+              <a:solidFill>
+                <a:srgbClr val="000000"/>
+              </a:solidFill>
+              <a:latin typeface="DejaVu Serif"/>
+            </a:endParaRPr>
+          </a:p>
+        </p:txBody>
+      </p:sp>
+      <p:sp>
+        <p:nvSpPr>
+          <p:cNvPr id="266" name=""/>
+          <p:cNvSpPr txBox="1"/>
+          <p:nvPr/>
+        </p:nvSpPr>
+        <p:spPr>
+          <a:xfrm>
+            <a:off x="2081880" y="2074680"/>
+            <a:ext cx="1599480" cy="145080"/>
+          </a:xfrm>
+          <a:prstGeom prst="rect">
+            <a:avLst/>
+          </a:prstGeom>
+          <a:noFill/>
+          <a:ln w="0">
+            <a:noFill/>
+          </a:ln>
+        </p:spPr>
+        <p:txBody>
+          <a:bodyPr lIns="0" rIns="0" tIns="0" bIns="0" anchor="t">
+            <a:noAutofit/>
+          </a:bodyPr>
+          <a:p>
+            <a:r>
+              <a:rPr b="0" lang="en-US" sz="980" spc="-1" strike="noStrike">
+                <a:solidFill>
+                  <a:srgbClr val="1a1a2e"/>
+                </a:solidFill>
+                <a:latin typeface="Arial"/>
+                <a:ea typeface="Arial"/>
+              </a:rPr>
+              <a:t>melding: aanbod gepland</a:t>
+            </a:r>
+            <a:endParaRPr b="0" lang="en-US" sz="980" spc="-1" strike="noStrike">
+              <a:solidFill>
+                <a:srgbClr val="000000"/>
+              </a:solidFill>
+              <a:latin typeface="DejaVu Serif"/>
+            </a:endParaRPr>
+          </a:p>
+        </p:txBody>
+      </p:sp>
+      <p:sp>
+        <p:nvSpPr>
+          <p:cNvPr id="267" name=""/>
+          <p:cNvSpPr txBox="1"/>
+          <p:nvPr/>
+        </p:nvSpPr>
+        <p:spPr>
+          <a:xfrm>
+            <a:off x="603720" y="2322360"/>
+            <a:ext cx="1509480" cy="145080"/>
+          </a:xfrm>
+          <a:prstGeom prst="rect">
+            <a:avLst/>
+          </a:prstGeom>
+          <a:noFill/>
+          <a:ln w="0">
+            <a:noFill/>
+          </a:ln>
+        </p:spPr>
+        <p:txBody>
+          <a:bodyPr lIns="0" rIns="0" tIns="0" bIns="0" anchor="t">
+            <a:noAutofit/>
+          </a:bodyPr>
+          <a:p>
+            <a:r>
+              <a:rPr b="1" lang="en-US" sz="980" spc="-1" strike="noStrike">
+                <a:solidFill>
+                  <a:srgbClr val="dd784b"/>
+                </a:solidFill>
+                <a:latin typeface="Arial"/>
+                <a:ea typeface="Arial"/>
+              </a:rPr>
+              <a:t>Catalogus </a:t>
+            </a:r>
+            <a:r>
+              <a:rPr b="1" lang="en-US" sz="980" spc="-1" strike="noStrike">
+                <a:solidFill>
+                  <a:srgbClr val="dd784b"/>
+                </a:solidFill>
+                <a:latin typeface="DejaVuSans"/>
+                <a:ea typeface="DejaVuSans"/>
+              </a:rPr>
+              <a:t>→ </a:t>
+            </a:r>
+            <a:r>
+              <a:rPr b="1" lang="en-US" sz="980" spc="-1" strike="noStrike">
+                <a:solidFill>
+                  <a:srgbClr val="dd784b"/>
+                </a:solidFill>
+                <a:latin typeface="Arial"/>
+                <a:ea typeface="Arial"/>
+              </a:rPr>
+              <a:t>Planning</a:t>
+            </a:r>
+            <a:endParaRPr b="0" lang="en-US" sz="980" spc="-1" strike="noStrike">
+              <a:solidFill>
+                <a:srgbClr val="000000"/>
+              </a:solidFill>
+              <a:latin typeface="DejaVu Serif"/>
+            </a:endParaRPr>
+          </a:p>
+        </p:txBody>
+      </p:sp>
+      <p:sp>
+        <p:nvSpPr>
+          <p:cNvPr id="268" name=""/>
+          <p:cNvSpPr txBox="1"/>
+          <p:nvPr/>
+        </p:nvSpPr>
+        <p:spPr>
+          <a:xfrm>
+            <a:off x="2081880" y="2322360"/>
+            <a:ext cx="1261080" cy="145080"/>
+          </a:xfrm>
+          <a:prstGeom prst="rect">
+            <a:avLst/>
+          </a:prstGeom>
+          <a:noFill/>
+          <a:ln w="0">
+            <a:noFill/>
+          </a:ln>
+        </p:spPr>
+        <p:txBody>
+          <a:bodyPr lIns="0" rIns="0" tIns="0" bIns="0" anchor="t">
+            <a:noAutofit/>
+          </a:bodyPr>
+          <a:p>
+            <a:r>
+              <a:rPr b="0" lang="en-US" sz="980" spc="-1" strike="noStrike">
+                <a:solidFill>
+                  <a:srgbClr val="1a1a2e"/>
+                </a:solidFill>
+                <a:latin typeface="Arial"/>
+                <a:ea typeface="Arial"/>
+              </a:rPr>
+              <a:t>haalt het aanbod op</a:t>
+            </a:r>
+            <a:endParaRPr b="0" lang="en-US" sz="980" spc="-1" strike="noStrike">
+              <a:solidFill>
+                <a:srgbClr val="000000"/>
+              </a:solidFill>
+              <a:latin typeface="DejaVu Serif"/>
+            </a:endParaRPr>
+          </a:p>
+        </p:txBody>
+      </p:sp>
+      <p:sp>
+        <p:nvSpPr>
+          <p:cNvPr id="269" name=""/>
+          <p:cNvSpPr txBox="1"/>
+          <p:nvPr/>
+        </p:nvSpPr>
+        <p:spPr>
+          <a:xfrm>
+            <a:off x="603720" y="2570040"/>
+            <a:ext cx="1509480" cy="145080"/>
+          </a:xfrm>
+          <a:prstGeom prst="rect">
+            <a:avLst/>
+          </a:prstGeom>
+          <a:noFill/>
+          <a:ln w="0">
+            <a:noFill/>
+          </a:ln>
+        </p:spPr>
+        <p:txBody>
+          <a:bodyPr lIns="0" rIns="0" tIns="0" bIns="0" anchor="t">
+            <a:noAutofit/>
+          </a:bodyPr>
+          <a:p>
+            <a:r>
+              <a:rPr b="1" lang="en-US" sz="980" spc="-1" strike="noStrike">
+                <a:solidFill>
+                  <a:srgbClr val="3d68ec"/>
+                </a:solidFill>
+                <a:latin typeface="Arial"/>
+                <a:ea typeface="Arial"/>
+              </a:rPr>
+              <a:t>Planning </a:t>
+            </a:r>
+            <a:r>
+              <a:rPr b="1" lang="en-US" sz="980" spc="-1" strike="noStrike">
+                <a:solidFill>
+                  <a:srgbClr val="3d68ec"/>
+                </a:solidFill>
+                <a:latin typeface="DejaVuSans"/>
+                <a:ea typeface="DejaVuSans"/>
+              </a:rPr>
+              <a:t>→ </a:t>
+            </a:r>
+            <a:r>
+              <a:rPr b="1" lang="en-US" sz="980" spc="-1" strike="noStrike">
+                <a:solidFill>
+                  <a:srgbClr val="3d68ec"/>
+                </a:solidFill>
+                <a:latin typeface="Arial"/>
+                <a:ea typeface="Arial"/>
+              </a:rPr>
+              <a:t>Catalogus</a:t>
+            </a:r>
+            <a:endParaRPr b="0" lang="en-US" sz="980" spc="-1" strike="noStrike">
+              <a:solidFill>
+                <a:srgbClr val="000000"/>
+              </a:solidFill>
+              <a:latin typeface="DejaVu Serif"/>
+            </a:endParaRPr>
+          </a:p>
+        </p:txBody>
+      </p:sp>
+      <p:sp>
+        <p:nvSpPr>
+          <p:cNvPr id="270" name=""/>
+          <p:cNvSpPr txBox="1"/>
+          <p:nvPr/>
+        </p:nvSpPr>
+        <p:spPr>
+          <a:xfrm>
+            <a:off x="2081880" y="2570040"/>
+            <a:ext cx="1945440" cy="145080"/>
+          </a:xfrm>
+          <a:prstGeom prst="rect">
+            <a:avLst/>
+          </a:prstGeom>
+          <a:noFill/>
+          <a:ln w="0">
+            <a:noFill/>
+          </a:ln>
+        </p:spPr>
+        <p:txBody>
+          <a:bodyPr lIns="0" rIns="0" tIns="0" bIns="0" anchor="t">
+            <a:noAutofit/>
+          </a:bodyPr>
+          <a:p>
+            <a:r>
+              <a:rPr b="0" lang="en-US" sz="980" spc="-1" strike="noStrike">
+                <a:solidFill>
+                  <a:srgbClr val="1a1a2e"/>
+                </a:solidFill>
+                <a:latin typeface="Arial"/>
+                <a:ea typeface="Arial"/>
+              </a:rPr>
+              <a:t>aanbod met verwijzing naar de</a:t>
+            </a:r>
+            <a:endParaRPr b="0" lang="en-US" sz="980" spc="-1" strike="noStrike">
+              <a:solidFill>
+                <a:srgbClr val="000000"/>
+              </a:solidFill>
+              <a:latin typeface="DejaVu Serif"/>
+            </a:endParaRPr>
+          </a:p>
+        </p:txBody>
+      </p:sp>
+      <p:sp>
+        <p:nvSpPr>
+          <p:cNvPr id="271" name=""/>
+          <p:cNvSpPr txBox="1"/>
+          <p:nvPr/>
+        </p:nvSpPr>
+        <p:spPr>
+          <a:xfrm>
+            <a:off x="2081880" y="2751120"/>
+            <a:ext cx="709560" cy="145080"/>
+          </a:xfrm>
+          <a:prstGeom prst="rect">
+            <a:avLst/>
+          </a:prstGeom>
+          <a:noFill/>
+          <a:ln w="0">
+            <a:noFill/>
+          </a:ln>
+        </p:spPr>
+        <p:txBody>
+          <a:bodyPr lIns="0" rIns="0" tIns="0" bIns="0" anchor="t">
+            <a:noAutofit/>
+          </a:bodyPr>
+          <a:p>
+            <a:r>
+              <a:rPr b="0" lang="en-US" sz="980" spc="-1" strike="noStrike">
+                <a:solidFill>
+                  <a:srgbClr val="1a1a2e"/>
+                </a:solidFill>
+                <a:latin typeface="Arial"/>
+                <a:ea typeface="Arial"/>
+              </a:rPr>
+              <a:t>speciﬁcatie</a:t>
+            </a:r>
+            <a:endParaRPr b="0" lang="en-US" sz="980" spc="-1" strike="noStrike">
+              <a:solidFill>
+                <a:srgbClr val="000000"/>
+              </a:solidFill>
+              <a:latin typeface="DejaVu Serif"/>
+            </a:endParaRPr>
+          </a:p>
+        </p:txBody>
+      </p:sp>
+      <p:sp>
+        <p:nvSpPr>
+          <p:cNvPr id="272" name=""/>
+          <p:cNvSpPr/>
+          <p:nvPr/>
+        </p:nvSpPr>
+        <p:spPr>
+          <a:xfrm>
+            <a:off x="599760" y="3619440"/>
+            <a:ext cx="1953000" cy="181080"/>
+          </a:xfrm>
+          <a:custGeom>
+            <a:avLst/>
+            <a:gdLst/>
+            <a:ahLst/>
+            <a:rect l="0" t="0" r="r" b="b"/>
+            <a:pathLst>
+              <a:path w="5425" h="503">
+                <a:moveTo>
+                  <a:pt x="0" y="398"/>
+                </a:moveTo>
+                <a:lnTo>
+                  <a:pt x="0" y="105"/>
+                </a:lnTo>
+                <a:cubicBezTo>
+                  <a:pt x="0" y="91"/>
+                  <a:pt x="3" y="78"/>
+                  <a:pt x="8" y="65"/>
+                </a:cubicBezTo>
+                <a:cubicBezTo>
+                  <a:pt x="14" y="52"/>
+                  <a:pt x="21" y="41"/>
+                  <a:pt x="31" y="31"/>
+                </a:cubicBezTo>
+                <a:cubicBezTo>
+                  <a:pt x="41" y="21"/>
+                  <a:pt x="53" y="13"/>
+                  <a:pt x="66" y="8"/>
+                </a:cubicBezTo>
+                <a:cubicBezTo>
+                  <a:pt x="79" y="2"/>
+                  <a:pt x="92" y="0"/>
+                  <a:pt x="106" y="0"/>
+                </a:cubicBezTo>
+                <a:lnTo>
+                  <a:pt x="5319" y="0"/>
+                </a:lnTo>
+                <a:cubicBezTo>
+                  <a:pt x="5334" y="0"/>
+                  <a:pt x="5347" y="2"/>
+                  <a:pt x="5360" y="8"/>
+                </a:cubicBezTo>
+                <a:cubicBezTo>
+                  <a:pt x="5373" y="13"/>
+                  <a:pt x="5384" y="21"/>
+                  <a:pt x="5394" y="31"/>
+                </a:cubicBezTo>
+                <a:cubicBezTo>
+                  <a:pt x="5404" y="41"/>
+                  <a:pt x="5412" y="52"/>
+                  <a:pt x="5417" y="65"/>
+                </a:cubicBezTo>
+                <a:cubicBezTo>
+                  <a:pt x="5423" y="78"/>
+                  <a:pt x="5425" y="91"/>
+                  <a:pt x="5425" y="105"/>
+                </a:cubicBezTo>
+                <a:lnTo>
+                  <a:pt x="5425" y="398"/>
+                </a:lnTo>
+                <a:cubicBezTo>
+                  <a:pt x="5425" y="412"/>
+                  <a:pt x="5423" y="425"/>
+                  <a:pt x="5417" y="438"/>
+                </a:cubicBezTo>
+                <a:cubicBezTo>
+                  <a:pt x="5412" y="451"/>
+                  <a:pt x="5404" y="462"/>
+                  <a:pt x="5394" y="472"/>
+                </a:cubicBezTo>
+                <a:cubicBezTo>
+                  <a:pt x="5384" y="482"/>
+                  <a:pt x="5373" y="490"/>
+                  <a:pt x="5360" y="495"/>
+                </a:cubicBezTo>
+                <a:cubicBezTo>
+                  <a:pt x="5347" y="501"/>
+                  <a:pt x="5334" y="503"/>
+                  <a:pt x="5319" y="503"/>
+                </a:cubicBezTo>
+                <a:lnTo>
+                  <a:pt x="106" y="503"/>
+                </a:lnTo>
+                <a:cubicBezTo>
+                  <a:pt x="92" y="503"/>
+                  <a:pt x="79" y="501"/>
+                  <a:pt x="66" y="495"/>
+                </a:cubicBezTo>
+                <a:cubicBezTo>
+                  <a:pt x="53" y="490"/>
+                  <a:pt x="41" y="482"/>
+                  <a:pt x="31" y="472"/>
+                </a:cubicBezTo>
+                <a:cubicBezTo>
+                  <a:pt x="21" y="462"/>
+                  <a:pt x="14" y="451"/>
+                  <a:pt x="8" y="438"/>
+                </a:cubicBezTo>
+                <a:cubicBezTo>
+                  <a:pt x="3" y="425"/>
+                  <a:pt x="0" y="412"/>
+                  <a:pt x="0" y="398"/>
+                </a:cubicBezTo>
+                <a:close/>
+              </a:path>
+            </a:pathLst>
+          </a:custGeom>
+          <a:solidFill>
+            <a:srgbClr val="f1f3f5"/>
+          </a:solidFill>
+          <a:ln w="0">
+            <a:noFill/>
+          </a:ln>
+        </p:spPr>
+        <p:txBody>
+          <a:bodyPr lIns="0" rIns="0" tIns="0" bIns="0" anchor="t">
+            <a:noAutofit/>
+          </a:bodyPr>
+          <a:p>
+            <a:endParaRPr b="0" lang="en-US" sz="2400" spc="-1" strike="noStrike">
+              <a:solidFill>
+                <a:srgbClr val="000000"/>
+              </a:solidFill>
+              <a:latin typeface="DejaVu Serif"/>
+            </a:endParaRPr>
+          </a:p>
+        </p:txBody>
+      </p:sp>
+      <p:sp>
+        <p:nvSpPr>
+          <p:cNvPr id="273" name=""/>
+          <p:cNvSpPr txBox="1"/>
+          <p:nvPr/>
+        </p:nvSpPr>
+        <p:spPr>
+          <a:xfrm>
+            <a:off x="603720" y="3317760"/>
+            <a:ext cx="707760" cy="163440"/>
+          </a:xfrm>
+          <a:prstGeom prst="rect">
+            <a:avLst/>
+          </a:prstGeom>
+          <a:noFill/>
+          <a:ln w="0">
+            <a:noFill/>
+          </a:ln>
+        </p:spPr>
+        <p:txBody>
+          <a:bodyPr lIns="0" rIns="0" tIns="0" bIns="0" anchor="t">
+            <a:noAutofit/>
+          </a:bodyPr>
+          <a:p>
+            <a:r>
+              <a:rPr b="1" lang="en-US" sz="1110" spc="-1" strike="noStrike">
+                <a:solidFill>
+                  <a:srgbClr val="1a1a2e"/>
+                </a:solidFill>
+                <a:latin typeface="Arial"/>
+                <a:ea typeface="Arial"/>
+              </a:rPr>
+              <a:t>Endpoint</a:t>
+            </a:r>
+            <a:endParaRPr b="0" lang="en-US" sz="1110" spc="-1" strike="noStrike">
+              <a:solidFill>
+                <a:srgbClr val="000000"/>
+              </a:solidFill>
+              <a:latin typeface="DejaVu Serif"/>
+            </a:endParaRPr>
+          </a:p>
+        </p:txBody>
+      </p:sp>
+      <p:sp>
+        <p:nvSpPr>
+          <p:cNvPr id="274" name=""/>
+          <p:cNvSpPr txBox="1"/>
+          <p:nvPr/>
+        </p:nvSpPr>
+        <p:spPr>
+          <a:xfrm>
+            <a:off x="660960" y="3630240"/>
+            <a:ext cx="1829520" cy="142200"/>
+          </a:xfrm>
+          <a:prstGeom prst="rect">
+            <a:avLst/>
+          </a:prstGeom>
+          <a:noFill/>
+          <a:ln w="0">
+            <a:noFill/>
+          </a:ln>
+        </p:spPr>
+        <p:txBody>
+          <a:bodyPr lIns="0" rIns="0" tIns="0" bIns="0" anchor="t">
+            <a:noAutofit/>
+          </a:bodyPr>
+          <a:p>
+            <a:r>
+              <a:rPr b="0" lang="en-US" sz="960" spc="-1" strike="noStrike">
+                <a:solidFill>
+                  <a:srgbClr val="dd784b"/>
+                </a:solidFill>
+                <a:latin typeface="DejaVuSansMono"/>
+                <a:ea typeface="DejaVuSansMono"/>
+              </a:rPr>
+              <a:t>GET /onderwijsaanbod/{id}</a:t>
+            </a:r>
+            <a:endParaRPr b="0" lang="en-US" sz="960" spc="-1" strike="noStrike">
+              <a:solidFill>
+                <a:srgbClr val="000000"/>
+              </a:solidFill>
+              <a:latin typeface="DejaVu Serif"/>
+            </a:endParaRPr>
+          </a:p>
+        </p:txBody>
+      </p:sp>
+      <p:sp>
+        <p:nvSpPr>
+          <p:cNvPr id="275" name=""/>
+          <p:cNvSpPr/>
+          <p:nvPr/>
+        </p:nvSpPr>
+        <p:spPr>
+          <a:xfrm>
+            <a:off x="4752720" y="1628640"/>
+            <a:ext cx="4124880" cy="2152800"/>
+          </a:xfrm>
+          <a:custGeom>
+            <a:avLst/>
+            <a:gdLst/>
+            <a:ahLst/>
+            <a:rect l="0" t="0" r="r" b="b"/>
+            <a:pathLst>
+              <a:path w="11458" h="5980">
+                <a:moveTo>
+                  <a:pt x="0" y="0"/>
+                </a:moveTo>
+                <a:lnTo>
+                  <a:pt x="11458" y="0"/>
+                </a:lnTo>
+                <a:lnTo>
+                  <a:pt x="11458" y="5980"/>
+                </a:lnTo>
+                <a:lnTo>
+                  <a:pt x="0" y="5980"/>
+                </a:lnTo>
+                <a:lnTo>
+                  <a:pt x="0" y="0"/>
+                </a:lnTo>
+                <a:close/>
+              </a:path>
+            </a:pathLst>
+          </a:custGeom>
+          <a:solidFill>
+            <a:srgbClr val="ffffff"/>
+          </a:solidFill>
+          <a:ln w="0">
+            <a:noFill/>
+          </a:ln>
+        </p:spPr>
+        <p:txBody>
+          <a:bodyPr lIns="0" rIns="0" tIns="0" bIns="0" anchor="t">
+            <a:noAutofit/>
+          </a:bodyPr>
+          <a:p>
+            <a:endParaRPr b="0" lang="en-US" sz="2400" spc="-1" strike="noStrike">
+              <a:solidFill>
+                <a:srgbClr val="000000"/>
+              </a:solidFill>
+              <a:latin typeface="DejaVu Serif"/>
+            </a:endParaRPr>
+          </a:p>
+        </p:txBody>
+      </p:sp>
+      <p:sp>
+        <p:nvSpPr>
+          <p:cNvPr id="276" name=""/>
+          <p:cNvSpPr/>
+          <p:nvPr/>
+        </p:nvSpPr>
+        <p:spPr>
+          <a:xfrm>
+            <a:off x="4752720" y="1628640"/>
+            <a:ext cx="4124880" cy="38520"/>
+          </a:xfrm>
+          <a:custGeom>
+            <a:avLst/>
+            <a:gdLst/>
+            <a:ahLst/>
+            <a:rect l="0" t="0" r="r" b="b"/>
+            <a:pathLst>
+              <a:path w="11458" h="107">
+                <a:moveTo>
+                  <a:pt x="0" y="0"/>
+                </a:moveTo>
+                <a:lnTo>
+                  <a:pt x="11458" y="0"/>
+                </a:lnTo>
+                <a:lnTo>
+                  <a:pt x="11458" y="107"/>
+                </a:lnTo>
+                <a:lnTo>
+                  <a:pt x="0" y="107"/>
+                </a:lnTo>
+                <a:lnTo>
+                  <a:pt x="0" y="0"/>
+                </a:lnTo>
+                <a:close/>
+              </a:path>
+            </a:pathLst>
+          </a:custGeom>
+          <a:solidFill>
+            <a:srgbClr val="00af81"/>
+          </a:solidFill>
+          <a:ln w="0">
+            <a:noFill/>
+          </a:ln>
+        </p:spPr>
+        <p:txBody>
+          <a:bodyPr lIns="0" rIns="0" tIns="0" bIns="0" anchor="t">
+            <a:noAutofit/>
+          </a:bodyPr>
+          <a:p>
+            <a:endParaRPr b="0" lang="en-US" sz="2400" spc="-1" strike="noStrike">
+              <a:solidFill>
+                <a:srgbClr val="000000"/>
+              </a:solidFill>
+              <a:latin typeface="DejaVu Serif"/>
+            </a:endParaRPr>
+          </a:p>
+        </p:txBody>
+      </p:sp>
+      <p:sp>
+        <p:nvSpPr>
+          <p:cNvPr id="277" name=""/>
+          <p:cNvSpPr/>
+          <p:nvPr/>
+        </p:nvSpPr>
+        <p:spPr>
+          <a:xfrm>
+            <a:off x="4752720" y="3771720"/>
+            <a:ext cx="4124880" cy="9720"/>
+          </a:xfrm>
+          <a:custGeom>
+            <a:avLst/>
+            <a:gdLst/>
+            <a:ahLst/>
+            <a:rect l="0" t="0" r="r" b="b"/>
+            <a:pathLst>
+              <a:path w="11458" h="27">
+                <a:moveTo>
+                  <a:pt x="0" y="0"/>
+                </a:moveTo>
+                <a:lnTo>
+                  <a:pt x="11458" y="0"/>
+                </a:lnTo>
+                <a:lnTo>
+                  <a:pt x="11458" y="27"/>
+                </a:lnTo>
+                <a:lnTo>
+                  <a:pt x="0" y="27"/>
+                </a:lnTo>
+                <a:lnTo>
+                  <a:pt x="0" y="0"/>
+                </a:lnTo>
+                <a:close/>
+              </a:path>
+            </a:pathLst>
+          </a:custGeom>
+          <a:solidFill>
+            <a:srgbClr val="e5e7eb"/>
+          </a:solidFill>
+          <a:ln w="0">
+            <a:noFill/>
+          </a:ln>
+        </p:spPr>
+        <p:txBody>
+          <a:bodyPr lIns="0" rIns="0" tIns="0" bIns="0" anchor="t">
+            <a:noAutofit/>
+          </a:bodyPr>
+          <a:p>
+            <a:endParaRPr b="0" lang="en-US" sz="2400" spc="-1" strike="noStrike">
+              <a:solidFill>
+                <a:srgbClr val="000000"/>
+              </a:solidFill>
+              <a:latin typeface="DejaVu Serif"/>
+            </a:endParaRPr>
+          </a:p>
+        </p:txBody>
+      </p:sp>
+      <p:sp>
+        <p:nvSpPr>
+          <p:cNvPr id="278" name=""/>
+          <p:cNvSpPr/>
+          <p:nvPr/>
+        </p:nvSpPr>
+        <p:spPr>
+          <a:xfrm>
+            <a:off x="8867520" y="1628640"/>
+            <a:ext cx="10080" cy="2152800"/>
+          </a:xfrm>
+          <a:custGeom>
+            <a:avLst/>
+            <a:gdLst/>
+            <a:ahLst/>
+            <a:rect l="0" t="0" r="r" b="b"/>
+            <a:pathLst>
+              <a:path w="28" h="5980">
+                <a:moveTo>
+                  <a:pt x="0" y="106"/>
+                </a:moveTo>
+                <a:lnTo>
+                  <a:pt x="0" y="5980"/>
+                </a:lnTo>
+                <a:lnTo>
+                  <a:pt x="28" y="5980"/>
+                </a:lnTo>
+                <a:lnTo>
+                  <a:pt x="28" y="0"/>
+                </a:lnTo>
+                <a:lnTo>
+                  <a:pt x="0" y="106"/>
+                </a:lnTo>
+                <a:close/>
+              </a:path>
+            </a:pathLst>
+          </a:custGeom>
+          <a:solidFill>
+            <a:srgbClr val="e5e7eb"/>
+          </a:solidFill>
+          <a:ln w="0">
+            <a:noFill/>
+          </a:ln>
+        </p:spPr>
+        <p:txBody>
+          <a:bodyPr lIns="0" rIns="0" tIns="0" bIns="0" anchor="t">
+            <a:noAutofit/>
+          </a:bodyPr>
+          <a:p>
+            <a:endParaRPr b="0" lang="en-US" sz="2400" spc="-1" strike="noStrike">
+              <a:solidFill>
+                <a:srgbClr val="000000"/>
+              </a:solidFill>
+              <a:latin typeface="DejaVu Serif"/>
+            </a:endParaRPr>
+          </a:p>
+        </p:txBody>
+      </p:sp>
+      <p:sp>
+        <p:nvSpPr>
+          <p:cNvPr id="279" name=""/>
+          <p:cNvSpPr/>
+          <p:nvPr/>
+        </p:nvSpPr>
+        <p:spPr>
+          <a:xfrm>
+            <a:off x="4752720" y="1628640"/>
+            <a:ext cx="10080" cy="2152800"/>
+          </a:xfrm>
+          <a:custGeom>
+            <a:avLst/>
+            <a:gdLst/>
+            <a:ahLst/>
+            <a:rect l="0" t="0" r="r" b="b"/>
+            <a:pathLst>
+              <a:path w="28" h="5980">
+                <a:moveTo>
+                  <a:pt x="0" y="0"/>
+                </a:moveTo>
+                <a:lnTo>
+                  <a:pt x="0" y="5980"/>
+                </a:lnTo>
+                <a:lnTo>
+                  <a:pt x="28" y="5980"/>
+                </a:lnTo>
+                <a:lnTo>
+                  <a:pt x="28" y="106"/>
+                </a:lnTo>
+                <a:lnTo>
+                  <a:pt x="0" y="0"/>
+                </a:lnTo>
+                <a:close/>
+              </a:path>
+            </a:pathLst>
+          </a:custGeom>
+          <a:solidFill>
+            <a:srgbClr val="e5e7eb"/>
+          </a:solidFill>
+          <a:ln w="0">
+            <a:noFill/>
+          </a:ln>
+        </p:spPr>
+        <p:txBody>
+          <a:bodyPr lIns="0" rIns="0" tIns="0" bIns="0" anchor="t">
+            <a:noAutofit/>
+          </a:bodyPr>
+          <a:p>
+            <a:endParaRPr b="0" lang="en-US" sz="2400" spc="-1" strike="noStrike">
+              <a:solidFill>
+                <a:srgbClr val="000000"/>
+              </a:solidFill>
+              <a:latin typeface="DejaVu Serif"/>
+            </a:endParaRPr>
+          </a:p>
+        </p:txBody>
+      </p:sp>
+      <p:sp>
+        <p:nvSpPr>
+          <p:cNvPr id="280" name=""/>
+          <p:cNvSpPr/>
+          <p:nvPr/>
+        </p:nvSpPr>
+        <p:spPr>
+          <a:xfrm>
+            <a:off x="4900320" y="2052360"/>
+            <a:ext cx="3829680" cy="1610280"/>
+          </a:xfrm>
+          <a:custGeom>
+            <a:avLst/>
+            <a:gdLst/>
+            <a:ahLst/>
+            <a:rect l="0" t="0" r="r" b="b"/>
+            <a:pathLst>
+              <a:path w="10638" h="4473">
+                <a:moveTo>
+                  <a:pt x="0" y="4327"/>
+                </a:moveTo>
+                <a:lnTo>
+                  <a:pt x="0" y="146"/>
+                </a:lnTo>
+                <a:cubicBezTo>
+                  <a:pt x="0" y="136"/>
+                  <a:pt x="1" y="127"/>
+                  <a:pt x="3" y="117"/>
+                </a:cubicBezTo>
+                <a:cubicBezTo>
+                  <a:pt x="5" y="108"/>
+                  <a:pt x="8" y="99"/>
+                  <a:pt x="11" y="90"/>
+                </a:cubicBezTo>
+                <a:cubicBezTo>
+                  <a:pt x="15" y="81"/>
+                  <a:pt x="20" y="73"/>
+                  <a:pt x="25" y="65"/>
+                </a:cubicBezTo>
+                <a:cubicBezTo>
+                  <a:pt x="30" y="57"/>
+                  <a:pt x="36" y="50"/>
+                  <a:pt x="43" y="43"/>
+                </a:cubicBezTo>
+                <a:cubicBezTo>
+                  <a:pt x="50" y="36"/>
+                  <a:pt x="57" y="30"/>
+                  <a:pt x="65" y="25"/>
+                </a:cubicBezTo>
+                <a:cubicBezTo>
+                  <a:pt x="73" y="19"/>
+                  <a:pt x="81" y="15"/>
+                  <a:pt x="90" y="11"/>
+                </a:cubicBezTo>
+                <a:cubicBezTo>
+                  <a:pt x="99" y="8"/>
+                  <a:pt x="108" y="5"/>
+                  <a:pt x="117" y="3"/>
+                </a:cubicBezTo>
+                <a:cubicBezTo>
+                  <a:pt x="127" y="1"/>
+                  <a:pt x="136" y="0"/>
+                  <a:pt x="146" y="0"/>
+                </a:cubicBezTo>
+                <a:lnTo>
+                  <a:pt x="10492" y="0"/>
+                </a:lnTo>
+                <a:cubicBezTo>
+                  <a:pt x="10502" y="0"/>
+                  <a:pt x="10511" y="1"/>
+                  <a:pt x="10520" y="3"/>
+                </a:cubicBezTo>
+                <a:cubicBezTo>
+                  <a:pt x="10530" y="5"/>
+                  <a:pt x="10539" y="8"/>
+                  <a:pt x="10548" y="11"/>
+                </a:cubicBezTo>
+                <a:cubicBezTo>
+                  <a:pt x="10557" y="15"/>
+                  <a:pt x="10565" y="19"/>
+                  <a:pt x="10573" y="25"/>
+                </a:cubicBezTo>
+                <a:cubicBezTo>
+                  <a:pt x="10581" y="30"/>
+                  <a:pt x="10588" y="36"/>
+                  <a:pt x="10595" y="43"/>
+                </a:cubicBezTo>
+                <a:cubicBezTo>
+                  <a:pt x="10602" y="50"/>
+                  <a:pt x="10608" y="57"/>
+                  <a:pt x="10613" y="65"/>
+                </a:cubicBezTo>
+                <a:cubicBezTo>
+                  <a:pt x="10618" y="73"/>
+                  <a:pt x="10623" y="81"/>
+                  <a:pt x="10626" y="90"/>
+                </a:cubicBezTo>
+                <a:cubicBezTo>
+                  <a:pt x="10630" y="99"/>
+                  <a:pt x="10633" y="108"/>
+                  <a:pt x="10635" y="117"/>
+                </a:cubicBezTo>
+                <a:cubicBezTo>
+                  <a:pt x="10637" y="127"/>
+                  <a:pt x="10638" y="136"/>
+                  <a:pt x="10638" y="146"/>
+                </a:cubicBezTo>
+                <a:lnTo>
+                  <a:pt x="10638" y="4327"/>
+                </a:lnTo>
+                <a:cubicBezTo>
+                  <a:pt x="10638" y="4337"/>
+                  <a:pt x="10637" y="4346"/>
+                  <a:pt x="10635" y="4356"/>
+                </a:cubicBezTo>
+                <a:cubicBezTo>
+                  <a:pt x="10633" y="4365"/>
+                  <a:pt x="10630" y="4374"/>
+                  <a:pt x="10626" y="4383"/>
+                </a:cubicBezTo>
+                <a:cubicBezTo>
+                  <a:pt x="10623" y="4392"/>
+                  <a:pt x="10618" y="4400"/>
+                  <a:pt x="10613" y="4408"/>
+                </a:cubicBezTo>
+                <a:cubicBezTo>
+                  <a:pt x="10608" y="4416"/>
+                  <a:pt x="10602" y="4423"/>
+                  <a:pt x="10595" y="4430"/>
+                </a:cubicBezTo>
+                <a:cubicBezTo>
+                  <a:pt x="10588" y="4437"/>
+                  <a:pt x="10581" y="4443"/>
+                  <a:pt x="10573" y="4448"/>
+                </a:cubicBezTo>
+                <a:cubicBezTo>
+                  <a:pt x="10565" y="4454"/>
+                  <a:pt x="10557" y="4458"/>
+                  <a:pt x="10548" y="4462"/>
+                </a:cubicBezTo>
+                <a:cubicBezTo>
+                  <a:pt x="10539" y="4465"/>
+                  <a:pt x="10530" y="4468"/>
+                  <a:pt x="10520" y="4470"/>
+                </a:cubicBezTo>
+                <a:cubicBezTo>
+                  <a:pt x="10511" y="4472"/>
+                  <a:pt x="10502" y="4473"/>
+                  <a:pt x="10492" y="4473"/>
+                </a:cubicBezTo>
+                <a:lnTo>
+                  <a:pt x="146" y="4473"/>
+                </a:lnTo>
+                <a:cubicBezTo>
+                  <a:pt x="136" y="4473"/>
+                  <a:pt x="127" y="4472"/>
+                  <a:pt x="117" y="4470"/>
+                </a:cubicBezTo>
+                <a:cubicBezTo>
+                  <a:pt x="108" y="4468"/>
+                  <a:pt x="99" y="4465"/>
+                  <a:pt x="90" y="4462"/>
+                </a:cubicBezTo>
+                <a:cubicBezTo>
+                  <a:pt x="81" y="4458"/>
+                  <a:pt x="73" y="4454"/>
+                  <a:pt x="65" y="4448"/>
+                </a:cubicBezTo>
+                <a:cubicBezTo>
+                  <a:pt x="57" y="4443"/>
+                  <a:pt x="50" y="4437"/>
+                  <a:pt x="43" y="4430"/>
+                </a:cubicBezTo>
+                <a:cubicBezTo>
+                  <a:pt x="36" y="4423"/>
+                  <a:pt x="30" y="4416"/>
+                  <a:pt x="25" y="4408"/>
+                </a:cubicBezTo>
+                <a:cubicBezTo>
+                  <a:pt x="20" y="4400"/>
+                  <a:pt x="15" y="4392"/>
+                  <a:pt x="11" y="4383"/>
+                </a:cubicBezTo>
+                <a:cubicBezTo>
+                  <a:pt x="8" y="4374"/>
+                  <a:pt x="5" y="4365"/>
+                  <a:pt x="3" y="4356"/>
+                </a:cubicBezTo>
+                <a:cubicBezTo>
+                  <a:pt x="1" y="4346"/>
+                  <a:pt x="0" y="4337"/>
+                  <a:pt x="0" y="4327"/>
+                </a:cubicBezTo>
+                <a:close/>
+              </a:path>
+            </a:pathLst>
+          </a:custGeom>
+          <a:solidFill>
+            <a:srgbClr val="f8f9fa"/>
+          </a:solidFill>
+          <a:ln w="0">
+            <a:noFill/>
+          </a:ln>
+        </p:spPr>
+        <p:txBody>
+          <a:bodyPr lIns="0" rIns="0" tIns="0" bIns="0" anchor="t">
+            <a:noAutofit/>
+          </a:bodyPr>
+          <a:p>
+            <a:endParaRPr b="0" lang="en-US" sz="2400" spc="-1" strike="noStrike">
+              <a:solidFill>
+                <a:srgbClr val="000000"/>
+              </a:solidFill>
+              <a:latin typeface="DejaVu Serif"/>
+            </a:endParaRPr>
+          </a:p>
+        </p:txBody>
+      </p:sp>
+      <p:sp>
+        <p:nvSpPr>
+          <p:cNvPr id="281" name=""/>
+          <p:cNvSpPr/>
+          <p:nvPr/>
+        </p:nvSpPr>
+        <p:spPr>
+          <a:xfrm>
+            <a:off x="4900320" y="2052360"/>
+            <a:ext cx="3829680" cy="1610280"/>
+          </a:xfrm>
+          <a:custGeom>
+            <a:avLst/>
+            <a:gdLst/>
+            <a:ahLst/>
+            <a:rect l="0" t="0" r="r" b="b"/>
+            <a:pathLst>
+              <a:path w="10638" h="4473">
+                <a:moveTo>
+                  <a:pt x="0" y="4327"/>
+                </a:moveTo>
+                <a:lnTo>
+                  <a:pt x="0" y="146"/>
+                </a:lnTo>
+                <a:cubicBezTo>
+                  <a:pt x="0" y="136"/>
+                  <a:pt x="1" y="127"/>
+                  <a:pt x="3" y="117"/>
+                </a:cubicBezTo>
+                <a:cubicBezTo>
+                  <a:pt x="5" y="108"/>
+                  <a:pt x="8" y="99"/>
+                  <a:pt x="11" y="90"/>
+                </a:cubicBezTo>
+                <a:cubicBezTo>
+                  <a:pt x="15" y="81"/>
+                  <a:pt x="20" y="73"/>
+                  <a:pt x="25" y="65"/>
+                </a:cubicBezTo>
+                <a:cubicBezTo>
+                  <a:pt x="30" y="57"/>
+                  <a:pt x="36" y="50"/>
+                  <a:pt x="43" y="43"/>
+                </a:cubicBezTo>
+                <a:cubicBezTo>
+                  <a:pt x="50" y="36"/>
+                  <a:pt x="57" y="30"/>
+                  <a:pt x="65" y="25"/>
+                </a:cubicBezTo>
+                <a:cubicBezTo>
+                  <a:pt x="73" y="19"/>
+                  <a:pt x="81" y="15"/>
+                  <a:pt x="90" y="11"/>
+                </a:cubicBezTo>
+                <a:cubicBezTo>
+                  <a:pt x="99" y="8"/>
+                  <a:pt x="108" y="5"/>
+                  <a:pt x="117" y="3"/>
+                </a:cubicBezTo>
+                <a:cubicBezTo>
+                  <a:pt x="127" y="1"/>
+                  <a:pt x="136" y="0"/>
+                  <a:pt x="146" y="0"/>
+                </a:cubicBezTo>
+                <a:lnTo>
+                  <a:pt x="10492" y="0"/>
+                </a:lnTo>
+                <a:cubicBezTo>
+                  <a:pt x="10502" y="0"/>
+                  <a:pt x="10511" y="1"/>
+                  <a:pt x="10520" y="3"/>
+                </a:cubicBezTo>
+                <a:cubicBezTo>
+                  <a:pt x="10530" y="5"/>
+                  <a:pt x="10539" y="8"/>
+                  <a:pt x="10548" y="11"/>
+                </a:cubicBezTo>
+                <a:cubicBezTo>
+                  <a:pt x="10557" y="15"/>
+                  <a:pt x="10565" y="19"/>
+                  <a:pt x="10573" y="25"/>
+                </a:cubicBezTo>
+                <a:cubicBezTo>
+                  <a:pt x="10581" y="30"/>
+                  <a:pt x="10588" y="36"/>
+                  <a:pt x="10595" y="43"/>
+                </a:cubicBezTo>
+                <a:cubicBezTo>
+                  <a:pt x="10602" y="50"/>
+                  <a:pt x="10608" y="57"/>
+                  <a:pt x="10613" y="65"/>
+                </a:cubicBezTo>
+                <a:cubicBezTo>
+                  <a:pt x="10618" y="73"/>
+                  <a:pt x="10623" y="81"/>
+                  <a:pt x="10626" y="90"/>
+                </a:cubicBezTo>
+                <a:cubicBezTo>
+                  <a:pt x="10630" y="99"/>
+                  <a:pt x="10633" y="108"/>
+                  <a:pt x="10635" y="117"/>
+                </a:cubicBezTo>
+                <a:cubicBezTo>
+                  <a:pt x="10637" y="127"/>
+                  <a:pt x="10638" y="136"/>
+                  <a:pt x="10638" y="146"/>
+                </a:cubicBezTo>
+                <a:lnTo>
+                  <a:pt x="10638" y="4327"/>
+                </a:lnTo>
+                <a:cubicBezTo>
+                  <a:pt x="10638" y="4337"/>
+                  <a:pt x="10637" y="4346"/>
+                  <a:pt x="10635" y="4356"/>
+                </a:cubicBezTo>
+                <a:cubicBezTo>
+                  <a:pt x="10633" y="4365"/>
+                  <a:pt x="10630" y="4374"/>
+                  <a:pt x="10626" y="4383"/>
+                </a:cubicBezTo>
+                <a:cubicBezTo>
+                  <a:pt x="10623" y="4392"/>
+                  <a:pt x="10618" y="4400"/>
+                  <a:pt x="10613" y="4408"/>
+                </a:cubicBezTo>
+                <a:cubicBezTo>
+                  <a:pt x="10608" y="4416"/>
+                  <a:pt x="10602" y="4423"/>
+                  <a:pt x="10595" y="4430"/>
+                </a:cubicBezTo>
+                <a:cubicBezTo>
+                  <a:pt x="10588" y="4437"/>
+                  <a:pt x="10581" y="4443"/>
+                  <a:pt x="10573" y="4448"/>
+                </a:cubicBezTo>
+                <a:cubicBezTo>
+                  <a:pt x="10565" y="4454"/>
+                  <a:pt x="10557" y="4458"/>
+                  <a:pt x="10548" y="4462"/>
+                </a:cubicBezTo>
+                <a:cubicBezTo>
+                  <a:pt x="10539" y="4465"/>
+                  <a:pt x="10530" y="4468"/>
+                  <a:pt x="10520" y="4470"/>
+                </a:cubicBezTo>
+                <a:cubicBezTo>
+                  <a:pt x="10511" y="4472"/>
+                  <a:pt x="10502" y="4473"/>
+                  <a:pt x="10492" y="4473"/>
+                </a:cubicBezTo>
+                <a:lnTo>
+                  <a:pt x="146" y="4473"/>
+                </a:lnTo>
+                <a:cubicBezTo>
+                  <a:pt x="136" y="4473"/>
+                  <a:pt x="127" y="4472"/>
+                  <a:pt x="117" y="4470"/>
+                </a:cubicBezTo>
+                <a:cubicBezTo>
+                  <a:pt x="108" y="4468"/>
+                  <a:pt x="99" y="4465"/>
+                  <a:pt x="90" y="4462"/>
+                </a:cubicBezTo>
+                <a:cubicBezTo>
+                  <a:pt x="81" y="4458"/>
+                  <a:pt x="73" y="4454"/>
+                  <a:pt x="65" y="4448"/>
+                </a:cubicBezTo>
+                <a:cubicBezTo>
+                  <a:pt x="57" y="4443"/>
+                  <a:pt x="50" y="4437"/>
+                  <a:pt x="43" y="4430"/>
+                </a:cubicBezTo>
+                <a:cubicBezTo>
+                  <a:pt x="36" y="4423"/>
+                  <a:pt x="30" y="4416"/>
+                  <a:pt x="25" y="4408"/>
+                </a:cubicBezTo>
+                <a:cubicBezTo>
+                  <a:pt x="20" y="4400"/>
+                  <a:pt x="15" y="4392"/>
+                  <a:pt x="11" y="4383"/>
+                </a:cubicBezTo>
+                <a:cubicBezTo>
+                  <a:pt x="8" y="4374"/>
+                  <a:pt x="5" y="4365"/>
+                  <a:pt x="3" y="4356"/>
+                </a:cubicBezTo>
+                <a:cubicBezTo>
+                  <a:pt x="1" y="4346"/>
+                  <a:pt x="0" y="4337"/>
+                  <a:pt x="0" y="4327"/>
+                </a:cubicBezTo>
+                <a:close/>
+              </a:path>
+            </a:pathLst>
+          </a:custGeom>
+          <a:noFill/>
+          <a:ln w="9360">
+            <a:solidFill>
+              <a:srgbClr val="e5e7eb"/>
+            </a:solidFill>
+            <a:miter/>
+          </a:ln>
+        </p:spPr>
+        <p:txBody>
+          <a:bodyPr lIns="4680" rIns="4680" tIns="4680" bIns="4680" anchor="t">
+            <a:noAutofit/>
+          </a:bodyPr>
+          <a:p>
+            <a:endParaRPr b="0" lang="en-US" sz="2400" spc="-1" strike="noStrike">
+              <a:solidFill>
+                <a:srgbClr val="000000"/>
+              </a:solidFill>
+              <a:latin typeface="DejaVu Serif"/>
+            </a:endParaRPr>
+          </a:p>
+        </p:txBody>
+      </p:sp>
+      <p:sp>
+        <p:nvSpPr>
+          <p:cNvPr id="282" name=""/>
+          <p:cNvSpPr txBox="1"/>
+          <p:nvPr/>
+        </p:nvSpPr>
+        <p:spPr>
+          <a:xfrm>
+            <a:off x="603720" y="3887280"/>
+            <a:ext cx="1538280" cy="142200"/>
+          </a:xfrm>
+          <a:prstGeom prst="rect">
+            <a:avLst/>
+          </a:prstGeom>
+          <a:noFill/>
+          <a:ln w="0">
+            <a:noFill/>
+          </a:ln>
+        </p:spPr>
+        <p:txBody>
+          <a:bodyPr lIns="0" rIns="0" tIns="0" bIns="0" anchor="t">
+            <a:noAutofit/>
+          </a:bodyPr>
+          <a:p>
+            <a:r>
+              <a:rPr b="0" lang="en-US" sz="960" spc="-1" strike="noStrike">
+                <a:solidFill>
+                  <a:srgbClr val="6b7280"/>
+                </a:solidFill>
+                <a:latin typeface="Arial"/>
+                <a:ea typeface="Arial"/>
+              </a:rPr>
+              <a:t>op het planningssysteem</a:t>
+            </a:r>
+            <a:endParaRPr b="0" lang="en-US" sz="960" spc="-1" strike="noStrike">
+              <a:solidFill>
+                <a:srgbClr val="000000"/>
+              </a:solidFill>
+              <a:latin typeface="DejaVu Serif"/>
+            </a:endParaRPr>
+          </a:p>
+        </p:txBody>
+      </p:sp>
+      <p:sp>
+        <p:nvSpPr>
+          <p:cNvPr id="283" name=""/>
+          <p:cNvSpPr txBox="1"/>
+          <p:nvPr/>
+        </p:nvSpPr>
+        <p:spPr>
+          <a:xfrm>
+            <a:off x="4897800" y="1793880"/>
+            <a:ext cx="1370880" cy="163440"/>
+          </a:xfrm>
+          <a:prstGeom prst="rect">
+            <a:avLst/>
+          </a:prstGeom>
+          <a:noFill/>
+          <a:ln w="0">
+            <a:noFill/>
+          </a:ln>
+        </p:spPr>
+        <p:txBody>
+          <a:bodyPr lIns="0" rIns="0" tIns="0" bIns="0" anchor="t">
+            <a:noAutofit/>
+          </a:bodyPr>
+          <a:p>
+            <a:r>
+              <a:rPr b="1" lang="en-US" sz="1110" spc="-1" strike="noStrike">
+                <a:solidFill>
+                  <a:srgbClr val="1a1a2e"/>
+                </a:solidFill>
+                <a:latin typeface="Arial"/>
+                <a:ea typeface="Arial"/>
+              </a:rPr>
+              <a:t>Voorbeeldbericht</a:t>
+            </a:r>
+            <a:endParaRPr b="0" lang="en-US" sz="1110" spc="-1" strike="noStrike">
+              <a:solidFill>
+                <a:srgbClr val="000000"/>
+              </a:solidFill>
+              <a:latin typeface="DejaVu Serif"/>
+            </a:endParaRPr>
+          </a:p>
+        </p:txBody>
+      </p:sp>
+      <p:sp>
+        <p:nvSpPr>
+          <p:cNvPr id="284" name=""/>
+          <p:cNvSpPr txBox="1"/>
+          <p:nvPr/>
+        </p:nvSpPr>
+        <p:spPr>
+          <a:xfrm>
+            <a:off x="5013720" y="2141280"/>
+            <a:ext cx="93960" cy="111960"/>
+          </a:xfrm>
+          <a:prstGeom prst="rect">
+            <a:avLst/>
+          </a:prstGeom>
+          <a:noFill/>
+          <a:ln w="0">
+            <a:noFill/>
+          </a:ln>
+        </p:spPr>
+        <p:txBody>
+          <a:bodyPr lIns="0" rIns="0" tIns="0" bIns="0" anchor="t">
+            <a:noAutofit/>
+          </a:bodyPr>
+          <a:p>
+            <a:r>
+              <a:rPr b="0" lang="en-US" sz="750" spc="-1" strike="noStrike">
+                <a:solidFill>
+                  <a:srgbClr val="1b2a6b"/>
+                </a:solidFill>
+                <a:latin typeface="DejaVuSansMono"/>
+                <a:ea typeface="DejaVuSansMono"/>
+              </a:rPr>
+              <a:t>{</a:t>
+            </a:r>
+            <a:endParaRPr b="0" lang="en-US" sz="750" spc="-1" strike="noStrike">
+              <a:solidFill>
+                <a:srgbClr val="000000"/>
+              </a:solidFill>
+              <a:latin typeface="DejaVu Serif"/>
+            </a:endParaRPr>
+          </a:p>
+        </p:txBody>
+      </p:sp>
+      <p:sp>
+        <p:nvSpPr>
+          <p:cNvPr id="285" name=""/>
+          <p:cNvSpPr txBox="1"/>
+          <p:nvPr/>
+        </p:nvSpPr>
+        <p:spPr>
+          <a:xfrm>
+            <a:off x="5013720" y="2284200"/>
+            <a:ext cx="1974240" cy="111960"/>
+          </a:xfrm>
+          <a:prstGeom prst="rect">
+            <a:avLst/>
+          </a:prstGeom>
+          <a:noFill/>
+          <a:ln w="0">
+            <a:noFill/>
+          </a:ln>
+        </p:spPr>
+        <p:txBody>
+          <a:bodyPr lIns="0" rIns="0" tIns="0" bIns="0" anchor="t">
+            <a:noAutofit/>
+          </a:bodyPr>
+          <a:p>
+            <a:r>
+              <a:rPr b="0" lang="en-US" sz="750" spc="-1" strike="noStrike">
+                <a:solidFill>
+                  <a:srgbClr val="1b2a6b"/>
+                </a:solidFill>
+                <a:latin typeface="DejaVuSansMono"/>
+                <a:ea typeface="DejaVuSansMono"/>
+              </a:rPr>
+              <a:t>  </a:t>
+            </a:r>
+            <a:r>
+              <a:rPr b="0" lang="en-US" sz="750" spc="-1" strike="noStrike">
+                <a:solidFill>
+                  <a:srgbClr val="3d68ec"/>
+                </a:solidFill>
+                <a:latin typeface="DejaVuSansMono"/>
+                <a:ea typeface="DejaVuSansMono"/>
+              </a:rPr>
+              <a:t>"aanbodType"</a:t>
+            </a:r>
+            <a:r>
+              <a:rPr b="0" lang="en-US" sz="750" spc="-1" strike="noStrike">
+                <a:solidFill>
+                  <a:srgbClr val="1b2a6b"/>
+                </a:solidFill>
+                <a:latin typeface="DejaVuSansMono"/>
+                <a:ea typeface="DejaVuSansMono"/>
+              </a:rPr>
+              <a:t>: "opleidingsaanbod",</a:t>
+            </a:r>
+            <a:endParaRPr b="0" lang="en-US" sz="750" spc="-1" strike="noStrike">
+              <a:solidFill>
+                <a:srgbClr val="000000"/>
+              </a:solidFill>
+              <a:latin typeface="DejaVu Serif"/>
+            </a:endParaRPr>
+          </a:p>
+        </p:txBody>
+      </p:sp>
+      <p:sp>
+        <p:nvSpPr>
+          <p:cNvPr id="286" name=""/>
+          <p:cNvSpPr txBox="1"/>
+          <p:nvPr/>
+        </p:nvSpPr>
+        <p:spPr>
+          <a:xfrm>
+            <a:off x="5013720" y="2426760"/>
+            <a:ext cx="2538000" cy="111960"/>
+          </a:xfrm>
+          <a:prstGeom prst="rect">
+            <a:avLst/>
+          </a:prstGeom>
+          <a:noFill/>
+          <a:ln w="0">
+            <a:noFill/>
+          </a:ln>
+        </p:spPr>
+        <p:txBody>
+          <a:bodyPr lIns="0" rIns="0" tIns="0" bIns="0" anchor="t">
+            <a:noAutofit/>
+          </a:bodyPr>
+          <a:p>
+            <a:r>
+              <a:rPr b="0" lang="en-US" sz="750" spc="-1" strike="noStrike">
+                <a:solidFill>
+                  <a:srgbClr val="1b2a6b"/>
+                </a:solidFill>
+                <a:latin typeface="DejaVuSansMono"/>
+                <a:ea typeface="DejaVuSansMono"/>
+              </a:rPr>
+              <a:t>  </a:t>
+            </a:r>
+            <a:r>
+              <a:rPr b="0" lang="en-US" sz="750" spc="-1" strike="noStrike">
+                <a:solidFill>
+                  <a:srgbClr val="3d68ec"/>
+                </a:solidFill>
+                <a:latin typeface="DejaVuSansMono"/>
+                <a:ea typeface="DejaVuSansMono"/>
+              </a:rPr>
+              <a:t>"naam"</a:t>
+            </a:r>
+            <a:r>
+              <a:rPr b="0" lang="en-US" sz="750" spc="-1" strike="noStrike">
+                <a:solidFill>
+                  <a:srgbClr val="1b2a6b"/>
+                </a:solidFill>
+                <a:latin typeface="DejaVuSansMono"/>
+                <a:ea typeface="DejaVuSansMono"/>
+              </a:rPr>
+              <a:t>: "Apothekersassistent, cohort 2026",</a:t>
+            </a:r>
+            <a:endParaRPr b="0" lang="en-US" sz="750" spc="-1" strike="noStrike">
+              <a:solidFill>
+                <a:srgbClr val="000000"/>
+              </a:solidFill>
+              <a:latin typeface="DejaVu Serif"/>
+            </a:endParaRPr>
+          </a:p>
+        </p:txBody>
+      </p:sp>
+      <p:sp>
+        <p:nvSpPr>
+          <p:cNvPr id="287" name=""/>
+          <p:cNvSpPr txBox="1"/>
+          <p:nvPr/>
+        </p:nvSpPr>
+        <p:spPr>
+          <a:xfrm>
+            <a:off x="5013720" y="2569680"/>
+            <a:ext cx="1241280" cy="111960"/>
+          </a:xfrm>
+          <a:prstGeom prst="rect">
+            <a:avLst/>
+          </a:prstGeom>
+          <a:noFill/>
+          <a:ln w="0">
+            <a:noFill/>
+          </a:ln>
+        </p:spPr>
+        <p:txBody>
+          <a:bodyPr lIns="0" rIns="0" tIns="0" bIns="0" anchor="t">
+            <a:noAutofit/>
+          </a:bodyPr>
+          <a:p>
+            <a:r>
+              <a:rPr b="0" lang="en-US" sz="750" spc="-1" strike="noStrike">
+                <a:solidFill>
+                  <a:srgbClr val="1b2a6b"/>
+                </a:solidFill>
+                <a:latin typeface="DejaVuSansMono"/>
+                <a:ea typeface="DejaVuSansMono"/>
+              </a:rPr>
+              <a:t>  </a:t>
+            </a:r>
+            <a:r>
+              <a:rPr b="0" lang="en-US" sz="750" spc="-1" strike="noStrike">
+                <a:solidFill>
+                  <a:srgbClr val="3d68ec"/>
+                </a:solidFill>
+                <a:latin typeface="DejaVuSansMono"/>
+                <a:ea typeface="DejaVuSansMono"/>
+              </a:rPr>
+              <a:t>"status"</a:t>
+            </a:r>
+            <a:r>
+              <a:rPr b="0" lang="en-US" sz="750" spc="-1" strike="noStrike">
+                <a:solidFill>
+                  <a:srgbClr val="1b2a6b"/>
+                </a:solidFill>
+                <a:latin typeface="DejaVuSansMono"/>
+                <a:ea typeface="DejaVuSansMono"/>
+              </a:rPr>
+              <a:t>: "gepland",</a:t>
+            </a:r>
+            <a:endParaRPr b="0" lang="en-US" sz="750" spc="-1" strike="noStrike">
+              <a:solidFill>
+                <a:srgbClr val="000000"/>
+              </a:solidFill>
+              <a:latin typeface="DejaVu Serif"/>
+            </a:endParaRPr>
+          </a:p>
+        </p:txBody>
+      </p:sp>
+      <p:sp>
+        <p:nvSpPr>
+          <p:cNvPr id="288" name=""/>
+          <p:cNvSpPr txBox="1"/>
+          <p:nvPr/>
+        </p:nvSpPr>
+        <p:spPr>
+          <a:xfrm>
+            <a:off x="5013720" y="2712600"/>
+            <a:ext cx="1635840" cy="111960"/>
+          </a:xfrm>
+          <a:prstGeom prst="rect">
+            <a:avLst/>
+          </a:prstGeom>
+          <a:noFill/>
+          <a:ln w="0">
+            <a:noFill/>
+          </a:ln>
+        </p:spPr>
+        <p:txBody>
+          <a:bodyPr lIns="0" rIns="0" tIns="0" bIns="0" anchor="t">
+            <a:noAutofit/>
+          </a:bodyPr>
+          <a:p>
+            <a:r>
+              <a:rPr b="0" lang="en-US" sz="750" spc="-1" strike="noStrike">
+                <a:solidFill>
+                  <a:srgbClr val="1b2a6b"/>
+                </a:solidFill>
+                <a:latin typeface="DejaVuSansMono"/>
+                <a:ea typeface="DejaVuSansMono"/>
+              </a:rPr>
+              <a:t>  </a:t>
+            </a:r>
+            <a:r>
+              <a:rPr b="0" lang="en-US" sz="750" spc="-1" strike="noStrike">
+                <a:solidFill>
+                  <a:srgbClr val="3d68ec"/>
+                </a:solidFill>
+                <a:latin typeface="DejaVuSansMono"/>
+                <a:ea typeface="DejaVuSansMono"/>
+              </a:rPr>
+              <a:t>"specificatieVerwijzing"</a:t>
+            </a:r>
+            <a:r>
+              <a:rPr b="0" lang="en-US" sz="750" spc="-1" strike="noStrike">
+                <a:solidFill>
+                  <a:srgbClr val="1b2a6b"/>
+                </a:solidFill>
+                <a:latin typeface="DejaVuSansMono"/>
+                <a:ea typeface="DejaVuSansMono"/>
+              </a:rPr>
+              <a:t>: {</a:t>
+            </a:r>
+            <a:endParaRPr b="0" lang="en-US" sz="750" spc="-1" strike="noStrike">
+              <a:solidFill>
+                <a:srgbClr val="000000"/>
+              </a:solidFill>
+              <a:latin typeface="DejaVu Serif"/>
+            </a:endParaRPr>
+          </a:p>
+        </p:txBody>
+      </p:sp>
+      <p:sp>
+        <p:nvSpPr>
+          <p:cNvPr id="289" name=""/>
+          <p:cNvSpPr txBox="1"/>
+          <p:nvPr/>
+        </p:nvSpPr>
+        <p:spPr>
+          <a:xfrm>
+            <a:off x="5013720" y="2855520"/>
+            <a:ext cx="2594880" cy="111960"/>
+          </a:xfrm>
+          <a:prstGeom prst="rect">
+            <a:avLst/>
+          </a:prstGeom>
+          <a:noFill/>
+          <a:ln w="0">
+            <a:noFill/>
+          </a:ln>
+        </p:spPr>
+        <p:txBody>
+          <a:bodyPr lIns="0" rIns="0" tIns="0" bIns="0" anchor="t">
+            <a:noAutofit/>
+          </a:bodyPr>
+          <a:p>
+            <a:r>
+              <a:rPr b="0" lang="en-US" sz="750" spc="-1" strike="noStrike">
+                <a:solidFill>
+                  <a:srgbClr val="1b2a6b"/>
+                </a:solidFill>
+                <a:latin typeface="DejaVuSansMono"/>
+                <a:ea typeface="DejaVuSansMono"/>
+              </a:rPr>
+              <a:t>    </a:t>
+            </a:r>
+            <a:r>
+              <a:rPr b="0" lang="en-US" sz="750" spc="-1" strike="noStrike">
+                <a:solidFill>
+                  <a:srgbClr val="1b2a6b"/>
+                </a:solidFill>
+                <a:latin typeface="DejaVuSansMono"/>
+                <a:ea typeface="DejaVuSansMono"/>
+              </a:rPr>
+              <a:t>"specificatieId": "79736830-1c5c-470f...",</a:t>
+            </a:r>
+            <a:endParaRPr b="0" lang="en-US" sz="750" spc="-1" strike="noStrike">
+              <a:solidFill>
+                <a:srgbClr val="000000"/>
+              </a:solidFill>
+              <a:latin typeface="DejaVu Serif"/>
+            </a:endParaRPr>
+          </a:p>
+        </p:txBody>
+      </p:sp>
+      <p:sp>
+        <p:nvSpPr>
+          <p:cNvPr id="290" name=""/>
+          <p:cNvSpPr txBox="1"/>
+          <p:nvPr/>
+        </p:nvSpPr>
+        <p:spPr>
+          <a:xfrm>
+            <a:off x="5013720" y="2998440"/>
+            <a:ext cx="1185120" cy="111960"/>
+          </a:xfrm>
+          <a:prstGeom prst="rect">
+            <a:avLst/>
+          </a:prstGeom>
+          <a:noFill/>
+          <a:ln w="0">
+            <a:noFill/>
+          </a:ln>
+        </p:spPr>
+        <p:txBody>
+          <a:bodyPr lIns="0" rIns="0" tIns="0" bIns="0" anchor="t">
+            <a:noAutofit/>
+          </a:bodyPr>
+          <a:p>
+            <a:r>
+              <a:rPr b="0" lang="en-US" sz="750" spc="-1" strike="noStrike">
+                <a:solidFill>
+                  <a:srgbClr val="1b2a6b"/>
+                </a:solidFill>
+                <a:latin typeface="DejaVuSansMono"/>
+                <a:ea typeface="DejaVuSansMono"/>
+              </a:rPr>
+              <a:t>    </a:t>
+            </a:r>
+            <a:r>
+              <a:rPr b="0" lang="en-US" sz="750" spc="-1" strike="noStrike">
+                <a:solidFill>
+                  <a:srgbClr val="1b2a6b"/>
+                </a:solidFill>
+                <a:latin typeface="DejaVuSansMono"/>
+                <a:ea typeface="DejaVuSansMono"/>
+              </a:rPr>
+              <a:t>"versie": "0.1.0"</a:t>
+            </a:r>
+            <a:endParaRPr b="0" lang="en-US" sz="750" spc="-1" strike="noStrike">
+              <a:solidFill>
+                <a:srgbClr val="000000"/>
+              </a:solidFill>
+              <a:latin typeface="DejaVu Serif"/>
+            </a:endParaRPr>
+          </a:p>
+        </p:txBody>
+      </p:sp>
+      <p:sp>
+        <p:nvSpPr>
+          <p:cNvPr id="291" name=""/>
+          <p:cNvSpPr txBox="1"/>
+          <p:nvPr/>
+        </p:nvSpPr>
+        <p:spPr>
+          <a:xfrm>
+            <a:off x="5013720" y="3141360"/>
+            <a:ext cx="226080" cy="111960"/>
+          </a:xfrm>
+          <a:prstGeom prst="rect">
+            <a:avLst/>
+          </a:prstGeom>
+          <a:noFill/>
+          <a:ln w="0">
+            <a:noFill/>
+          </a:ln>
+        </p:spPr>
+        <p:txBody>
+          <a:bodyPr lIns="0" rIns="0" tIns="0" bIns="0" anchor="t">
+            <a:noAutofit/>
+          </a:bodyPr>
+          <a:p>
+            <a:r>
+              <a:rPr b="0" lang="en-US" sz="750" spc="-1" strike="noStrike">
+                <a:solidFill>
+                  <a:srgbClr val="1b2a6b"/>
+                </a:solidFill>
+                <a:latin typeface="DejaVuSansMono"/>
+                <a:ea typeface="DejaVuSansMono"/>
+              </a:rPr>
+              <a:t>  </a:t>
+            </a:r>
+            <a:r>
+              <a:rPr b="0" lang="en-US" sz="750" spc="-1" strike="noStrike">
+                <a:solidFill>
+                  <a:srgbClr val="1b2a6b"/>
+                </a:solidFill>
+                <a:latin typeface="DejaVuSansMono"/>
+                <a:ea typeface="DejaVuSansMono"/>
+              </a:rPr>
+              <a:t>},</a:t>
+            </a:r>
+            <a:endParaRPr b="0" lang="en-US" sz="750" spc="-1" strike="noStrike">
+              <a:solidFill>
+                <a:srgbClr val="000000"/>
+              </a:solidFill>
+              <a:latin typeface="DejaVu Serif"/>
+            </a:endParaRPr>
+          </a:p>
+        </p:txBody>
+      </p:sp>
+      <p:sp>
+        <p:nvSpPr>
+          <p:cNvPr id="292" name=""/>
+          <p:cNvSpPr txBox="1"/>
+          <p:nvPr/>
+        </p:nvSpPr>
+        <p:spPr>
+          <a:xfrm>
+            <a:off x="5013720" y="3274560"/>
+            <a:ext cx="3384000" cy="111960"/>
+          </a:xfrm>
+          <a:prstGeom prst="rect">
+            <a:avLst/>
+          </a:prstGeom>
+          <a:noFill/>
+          <a:ln w="0">
+            <a:noFill/>
+          </a:ln>
+        </p:spPr>
+        <p:txBody>
+          <a:bodyPr lIns="0" rIns="0" tIns="0" bIns="0" anchor="t">
+            <a:noAutofit/>
+          </a:bodyPr>
+          <a:p>
+            <a:r>
+              <a:rPr b="0" lang="en-US" sz="750" spc="-1" strike="noStrike">
+                <a:solidFill>
+                  <a:srgbClr val="1b2a6b"/>
+                </a:solidFill>
+                <a:latin typeface="DejaVuSansMono"/>
+                <a:ea typeface="DejaVuSansMono"/>
+              </a:rPr>
+              <a:t>  </a:t>
+            </a:r>
+            <a:r>
+              <a:rPr b="0" lang="en-US" sz="750" spc="-1" strike="noStrike">
+                <a:solidFill>
+                  <a:srgbClr val="3d68ec"/>
+                </a:solidFill>
+                <a:latin typeface="DejaVuSansMono"/>
+                <a:ea typeface="DejaVuSansMono"/>
+              </a:rPr>
+              <a:t>"periode"</a:t>
+            </a:r>
+            <a:r>
+              <a:rPr b="0" lang="en-US" sz="750" spc="-1" strike="noStrike">
+                <a:solidFill>
+                  <a:srgbClr val="1b2a6b"/>
+                </a:solidFill>
+                <a:latin typeface="DejaVuSansMono"/>
+                <a:ea typeface="DejaVuSansMono"/>
+              </a:rPr>
+              <a:t>: { "start": "2026-09-01", "eind": "2029-07-15" }</a:t>
+            </a:r>
+            <a:endParaRPr b="0" lang="en-US" sz="750" spc="-1" strike="noStrike">
+              <a:solidFill>
+                <a:srgbClr val="000000"/>
+              </a:solidFill>
+              <a:latin typeface="DejaVu Serif"/>
+            </a:endParaRPr>
+          </a:p>
+        </p:txBody>
+      </p:sp>
+      <p:sp>
+        <p:nvSpPr>
+          <p:cNvPr id="293" name=""/>
+          <p:cNvSpPr txBox="1"/>
+          <p:nvPr/>
+        </p:nvSpPr>
+        <p:spPr>
+          <a:xfrm>
+            <a:off x="5013720" y="3417480"/>
+            <a:ext cx="93960" cy="111960"/>
+          </a:xfrm>
+          <a:prstGeom prst="rect">
+            <a:avLst/>
+          </a:prstGeom>
+          <a:noFill/>
+          <a:ln w="0">
+            <a:noFill/>
+          </a:ln>
+        </p:spPr>
+        <p:txBody>
+          <a:bodyPr lIns="0" rIns="0" tIns="0" bIns="0" anchor="t">
+            <a:noAutofit/>
+          </a:bodyPr>
+          <a:p>
+            <a:r>
+              <a:rPr b="0" lang="en-US" sz="750" spc="-1" strike="noStrike">
+                <a:solidFill>
+                  <a:srgbClr val="1b2a6b"/>
+                </a:solidFill>
+                <a:latin typeface="DejaVuSansMono"/>
+                <a:ea typeface="DejaVuSansMono"/>
+              </a:rPr>
+              <a:t>}</a:t>
+            </a:r>
+            <a:endParaRPr b="0" lang="en-US" sz="750" spc="-1" strike="noStrike">
+              <a:solidFill>
+                <a:srgbClr val="000000"/>
+              </a:solidFill>
+              <a:latin typeface="DejaVu Serif"/>
+            </a:endParaRPr>
+          </a:p>
+        </p:txBody>
+      </p:sp>
+      <p:sp>
+        <p:nvSpPr>
+          <p:cNvPr id="294" name=""/>
+          <p:cNvSpPr/>
+          <p:nvPr/>
+        </p:nvSpPr>
+        <p:spPr>
+          <a:xfrm>
+            <a:off x="0" y="5257440"/>
+            <a:ext cx="9334800" cy="5258160"/>
+          </a:xfrm>
+          <a:custGeom>
+            <a:avLst/>
+            <a:gdLst/>
+            <a:ahLst/>
+            <a:rect l="0" t="0" r="r" b="b"/>
+            <a:pathLst>
+              <a:path w="25930" h="14606">
+                <a:moveTo>
+                  <a:pt x="0" y="0"/>
+                </a:moveTo>
+                <a:lnTo>
+                  <a:pt x="25930" y="0"/>
+                </a:lnTo>
+                <a:lnTo>
+                  <a:pt x="25930" y="14606"/>
+                </a:lnTo>
+                <a:lnTo>
+                  <a:pt x="0" y="14606"/>
+                </a:lnTo>
+                <a:lnTo>
+                  <a:pt x="0" y="0"/>
+                </a:lnTo>
+                <a:close/>
+              </a:path>
+            </a:pathLst>
+          </a:custGeom>
+          <a:solidFill>
+            <a:srgbClr val="ffffff"/>
+          </a:solidFill>
+          <a:ln w="0">
+            <a:noFill/>
+          </a:ln>
+        </p:spPr>
+        <p:txBody>
+          <a:bodyPr lIns="0" rIns="0" tIns="0" bIns="0" anchor="t">
+            <a:noAutofit/>
+          </a:bodyPr>
+          <a:p>
+            <a:endParaRPr b="0" lang="en-US" sz="2400" spc="-1" strike="noStrike">
+              <a:solidFill>
+                <a:srgbClr val="000000"/>
+              </a:solidFill>
+              <a:latin typeface="DejaVu Serif"/>
+            </a:endParaRPr>
+          </a:p>
+        </p:txBody>
+      </p:sp>
+      <p:sp>
+        <p:nvSpPr>
+          <p:cNvPr id="295" name=""/>
+          <p:cNvSpPr txBox="1"/>
+          <p:nvPr/>
+        </p:nvSpPr>
+        <p:spPr>
+          <a:xfrm>
+            <a:off x="2709720" y="4318560"/>
+            <a:ext cx="4329000" cy="151200"/>
+          </a:xfrm>
+          <a:prstGeom prst="rect">
+            <a:avLst/>
+          </a:prstGeom>
+          <a:noFill/>
+          <a:ln w="0">
+            <a:noFill/>
+          </a:ln>
+        </p:spPr>
+        <p:txBody>
+          <a:bodyPr lIns="0" rIns="0" tIns="0" bIns="0" anchor="t">
+            <a:noAutofit/>
+          </a:bodyPr>
+          <a:p>
+            <a:r>
+              <a:rPr b="0" lang="en-US" sz="1020" spc="-1" strike="noStrike">
+                <a:solidFill>
+                  <a:srgbClr val="6b7280"/>
+                </a:solidFill>
+                <a:latin typeface="Arial"/>
+                <a:ea typeface="Arial"/>
+              </a:rPr>
+              <a:t>Endpoint, interactie en schema: bouwblokken van het eindproduct</a:t>
+            </a:r>
+            <a:endParaRPr b="0" lang="en-US" sz="1020" spc="-1" strike="noStrike">
+              <a:solidFill>
+                <a:srgbClr val="000000"/>
+              </a:solidFill>
+              <a:latin typeface="DejaVu Serif"/>
+            </a:endParaRPr>
+          </a:p>
+        </p:txBody>
+      </p:sp>
+    </p:spTree>
+  </p:cSld>
+  <mc:AlternateContent>
+    <mc:Choice Requires="p14">
+      <p:transition spd="slow" p14:dur="2000"/>
+    </mc:Choice>
+    <mc:Fallback>
+      <p:transition spd="slow"/>
+    </mc:Fallback>
+  </mc:AlternateContent>
+</p:sld>
+</file>
+
+<file path=ppt/slides/slide7.xml><?xml version="1.0" encoding="utf-8"?>
+<p:sld xmlns:a="http://schemas.openxmlformats.org/drawingml/2006/main" xmlns:p="http://schemas.openxmlformats.org/presentationml/2006/main" xmlns:r="http://schemas.openxmlformats.org/officeDocument/2006/relationships" xmlns:p14="http://schemas.microsoft.com/office/powerpoint/2010/main" xmlns:p15="http://schemas.microsoft.com/office/powerpoint/2012/main" xmlns:mc="http://schemas.openxmlformats.org/markup-compatibility/2006">
+  <p:cSld>
+    <p:spTree>
+      <p:nvGrpSpPr>
+        <p:cNvPr id="1" name=""/>
+        <p:cNvGrpSpPr/>
+        <p:nvPr/>
+      </p:nvGrpSpPr>
+      <p:grpSpPr>
+        <a:xfrm>
+          <a:off x="0" y="0"/>
+          <a:ext cx="0" cy="0"/>
+          <a:chOff x="0" y="0"/>
+          <a:chExt cx="0" cy="0"/>
+        </a:xfrm>
+      </p:grpSpPr>
+      <p:sp>
+        <p:nvSpPr>
+          <p:cNvPr id="296" name=""/>
+          <p:cNvSpPr/>
+          <p:nvPr/>
+        </p:nvSpPr>
+        <p:spPr>
+          <a:xfrm>
+            <a:off x="0" y="0"/>
+            <a:ext cx="9334800" cy="5257800"/>
+          </a:xfrm>
+          <a:custGeom>
+            <a:avLst/>
+            <a:gdLst/>
+            <a:ahLst/>
+            <a:rect l="0" t="0" r="r" b="b"/>
+            <a:pathLst>
+              <a:path w="25930" h="14605">
+                <a:moveTo>
+                  <a:pt x="0" y="0"/>
+                </a:moveTo>
+                <a:lnTo>
+                  <a:pt x="25930" y="0"/>
+                </a:lnTo>
+                <a:lnTo>
+                  <a:pt x="25930" y="14605"/>
+                </a:lnTo>
+                <a:lnTo>
+                  <a:pt x="0" y="14605"/>
+                </a:lnTo>
+                <a:lnTo>
+                  <a:pt x="0" y="0"/>
+                </a:lnTo>
+                <a:close/>
+              </a:path>
+            </a:pathLst>
+          </a:custGeom>
+          <a:solidFill>
+            <a:srgbClr val="ffffff"/>
+          </a:solidFill>
+          <a:ln w="0">
+            <a:noFill/>
+          </a:ln>
+        </p:spPr>
+        <p:txBody>
+          <a:bodyPr lIns="0" rIns="0" tIns="0" bIns="0" anchor="t">
+            <a:noAutofit/>
+          </a:bodyPr>
+          <a:p>
+            <a:endParaRPr b="0" lang="en-US" sz="2400" spc="-1" strike="noStrike">
+              <a:solidFill>
+                <a:srgbClr val="000000"/>
+              </a:solidFill>
+              <a:latin typeface="DejaVu Serif"/>
+            </a:endParaRPr>
+          </a:p>
+        </p:txBody>
+      </p:sp>
+      <p:sp>
+        <p:nvSpPr>
+          <p:cNvPr id="297" name=""/>
+          <p:cNvSpPr/>
+          <p:nvPr/>
+        </p:nvSpPr>
+        <p:spPr>
+          <a:xfrm>
+            <a:off x="0" y="0"/>
+            <a:ext cx="9334800" cy="5257800"/>
+          </a:xfrm>
+          <a:custGeom>
+            <a:avLst/>
+            <a:gdLst/>
+            <a:ahLst/>
+            <a:rect l="0" t="0" r="r" b="b"/>
+            <a:pathLst>
+              <a:path w="25930" h="14605">
+                <a:moveTo>
+                  <a:pt x="0" y="0"/>
+                </a:moveTo>
+                <a:lnTo>
+                  <a:pt x="25930" y="0"/>
+                </a:lnTo>
+                <a:lnTo>
+                  <a:pt x="25930" y="14605"/>
+                </a:lnTo>
+                <a:lnTo>
+                  <a:pt x="0" y="14605"/>
+                </a:lnTo>
+                <a:lnTo>
+                  <a:pt x="0" y="0"/>
+                </a:lnTo>
+                <a:close/>
+              </a:path>
+            </a:pathLst>
+          </a:custGeom>
+          <a:solidFill>
+            <a:srgbClr val="ffffff"/>
+          </a:solidFill>
+          <a:ln w="0">
+            <a:noFill/>
+          </a:ln>
+        </p:spPr>
+        <p:txBody>
+          <a:bodyPr lIns="0" rIns="0" tIns="0" bIns="0" anchor="t">
+            <a:noAutofit/>
+          </a:bodyPr>
+          <a:p>
+            <a:endParaRPr b="0" lang="en-US" sz="2400" spc="-1" strike="noStrike">
+              <a:solidFill>
+                <a:srgbClr val="000000"/>
+              </a:solidFill>
+              <a:latin typeface="DejaVu Serif"/>
+            </a:endParaRPr>
+          </a:p>
+        </p:txBody>
+      </p:sp>
+      <p:sp>
+        <p:nvSpPr>
+          <p:cNvPr id="298" name=""/>
+          <p:cNvSpPr/>
+          <p:nvPr/>
+        </p:nvSpPr>
+        <p:spPr>
+          <a:xfrm>
+            <a:off x="0" y="0"/>
+            <a:ext cx="9334800" cy="5257800"/>
+          </a:xfrm>
+          <a:custGeom>
+            <a:avLst/>
+            <a:gdLst/>
+            <a:ahLst/>
+            <a:rect l="0" t="0" r="r" b="b"/>
+            <a:pathLst>
+              <a:path w="25930" h="14605">
+                <a:moveTo>
+                  <a:pt x="0" y="0"/>
+                </a:moveTo>
+                <a:lnTo>
+                  <a:pt x="25930" y="0"/>
+                </a:lnTo>
+                <a:lnTo>
+                  <a:pt x="25930" y="14605"/>
+                </a:lnTo>
+                <a:lnTo>
+                  <a:pt x="0" y="14605"/>
+                </a:lnTo>
+                <a:lnTo>
+                  <a:pt x="0" y="0"/>
+                </a:lnTo>
+                <a:close/>
+              </a:path>
+            </a:pathLst>
+          </a:custGeom>
+          <a:solidFill>
+            <a:srgbClr val="ffffff"/>
+          </a:solidFill>
+          <a:ln w="0">
+            <a:noFill/>
+          </a:ln>
+        </p:spPr>
+        <p:txBody>
+          <a:bodyPr lIns="0" rIns="0" tIns="0" bIns="0" anchor="t">
+            <a:noAutofit/>
+          </a:bodyPr>
+          <a:p>
+            <a:endParaRPr b="0" lang="en-US" sz="2400" spc="-1" strike="noStrike">
+              <a:solidFill>
+                <a:srgbClr val="000000"/>
+              </a:solidFill>
+              <a:latin typeface="DejaVu Serif"/>
+            </a:endParaRPr>
+          </a:p>
+        </p:txBody>
+      </p:sp>
+      <p:sp>
+        <p:nvSpPr>
+          <p:cNvPr id="299" name=""/>
+          <p:cNvSpPr/>
+          <p:nvPr/>
+        </p:nvSpPr>
+        <p:spPr>
+          <a:xfrm>
+            <a:off x="0" y="0"/>
+            <a:ext cx="9334800" cy="5257800"/>
+          </a:xfrm>
+          <a:custGeom>
+            <a:avLst/>
+            <a:gdLst/>
+            <a:ahLst/>
+            <a:rect l="0" t="0" r="r" b="b"/>
+            <a:pathLst>
+              <a:path w="25930" h="14605">
+                <a:moveTo>
+                  <a:pt x="0" y="0"/>
+                </a:moveTo>
+                <a:lnTo>
+                  <a:pt x="25930" y="0"/>
+                </a:lnTo>
+                <a:lnTo>
+                  <a:pt x="25930" y="14605"/>
+                </a:lnTo>
+                <a:lnTo>
+                  <a:pt x="0" y="14605"/>
+                </a:lnTo>
+                <a:lnTo>
+                  <a:pt x="0" y="0"/>
+                </a:lnTo>
+                <a:close/>
+              </a:path>
+            </a:pathLst>
+          </a:custGeom>
+          <a:solidFill>
+            <a:srgbClr val="000000"/>
+          </a:solidFill>
+          <a:ln w="0">
+            <a:noFill/>
+          </a:ln>
+        </p:spPr>
+        <p:txBody>
+          <a:bodyPr lIns="0" rIns="0" tIns="0" bIns="0" anchor="t">
+            <a:noAutofit/>
+          </a:bodyPr>
+          <a:p>
+            <a:endParaRPr b="0" lang="en-US" sz="2400" spc="-1" strike="noStrike">
+              <a:solidFill>
+                <a:srgbClr val="ffffff"/>
+              </a:solidFill>
+              <a:latin typeface="DejaVu Serif"/>
+            </a:endParaRPr>
+          </a:p>
+        </p:txBody>
+      </p:sp>
+      <p:sp>
+        <p:nvSpPr>
+          <p:cNvPr id="300" name=""/>
+          <p:cNvSpPr/>
+          <p:nvPr/>
+        </p:nvSpPr>
+        <p:spPr>
+          <a:xfrm>
+            <a:off x="0" y="-5257800"/>
+            <a:ext cx="9334800" cy="5258160"/>
+          </a:xfrm>
+          <a:custGeom>
+            <a:avLst/>
+            <a:gdLst/>
+            <a:ahLst/>
+            <a:rect l="0" t="0" r="r" b="b"/>
+            <a:pathLst>
+              <a:path w="25930" h="14606">
+                <a:moveTo>
+                  <a:pt x="0" y="0"/>
+                </a:moveTo>
+                <a:lnTo>
+                  <a:pt x="25930" y="0"/>
+                </a:lnTo>
+                <a:lnTo>
+                  <a:pt x="25930" y="14606"/>
+                </a:lnTo>
+                <a:lnTo>
+                  <a:pt x="0" y="14606"/>
+                </a:lnTo>
+                <a:lnTo>
+                  <a:pt x="0" y="0"/>
+                </a:lnTo>
+                <a:close/>
+              </a:path>
+            </a:pathLst>
+          </a:custGeom>
+          <a:solidFill>
+            <a:srgbClr val="ffffff"/>
+          </a:solidFill>
+          <a:ln w="0">
+            <a:noFill/>
+          </a:ln>
+        </p:spPr>
+        <p:txBody>
+          <a:bodyPr lIns="0" rIns="0" tIns="0" bIns="0" anchor="t">
+            <a:noAutofit/>
+          </a:bodyPr>
+          <a:p>
+            <a:endParaRPr b="0" lang="en-US" sz="2400" spc="-1" strike="noStrike">
+              <a:solidFill>
+                <a:srgbClr val="000000"/>
+              </a:solidFill>
+              <a:latin typeface="DejaVu Serif"/>
+            </a:endParaRPr>
+          </a:p>
+        </p:txBody>
+      </p:sp>
+      <p:sp>
+        <p:nvSpPr>
+          <p:cNvPr id="301" name=""/>
+          <p:cNvSpPr/>
+          <p:nvPr/>
+        </p:nvSpPr>
+        <p:spPr>
+          <a:xfrm>
+            <a:off x="0" y="0"/>
+            <a:ext cx="9334800" cy="5257800"/>
+          </a:xfrm>
+          <a:custGeom>
+            <a:avLst/>
+            <a:gdLst/>
+            <a:ahLst/>
+            <a:rect l="0" t="0" r="r" b="b"/>
+            <a:pathLst>
+              <a:path w="25930" h="14605">
+                <a:moveTo>
+                  <a:pt x="0" y="0"/>
+                </a:moveTo>
+                <a:lnTo>
+                  <a:pt x="25930" y="0"/>
+                </a:lnTo>
+                <a:lnTo>
+                  <a:pt x="25930" y="14605"/>
+                </a:lnTo>
+                <a:lnTo>
+                  <a:pt x="0" y="14605"/>
+                </a:lnTo>
+                <a:lnTo>
+                  <a:pt x="0" y="0"/>
+                </a:lnTo>
+                <a:close/>
+              </a:path>
+            </a:pathLst>
+          </a:custGeom>
+          <a:solidFill>
+            <a:srgbClr val="ffffff"/>
+          </a:solidFill>
+          <a:ln w="0">
+            <a:noFill/>
+          </a:ln>
+        </p:spPr>
+        <p:txBody>
+          <a:bodyPr lIns="0" rIns="0" tIns="0" bIns="0" anchor="t">
+            <a:noAutofit/>
+          </a:bodyPr>
+          <a:p>
+            <a:endParaRPr b="0" lang="en-US" sz="2400" spc="-1" strike="noStrike">
+              <a:solidFill>
+                <a:srgbClr val="000000"/>
+              </a:solidFill>
+              <a:latin typeface="DejaVu Serif"/>
+            </a:endParaRPr>
+          </a:p>
+        </p:txBody>
+      </p:sp>
+      <p:pic>
+        <p:nvPicPr>
+          <p:cNvPr id="302" name="" descr=""/>
+          <p:cNvPicPr/>
+          <p:nvPr/>
+        </p:nvPicPr>
+        <p:blipFill>
+          <a:blip r:embed="rId1"/>
+          <a:stretch/>
+        </p:blipFill>
+        <p:spPr>
+          <a:xfrm>
+            <a:off x="-6120" y="0"/>
+            <a:ext cx="9346680" cy="5257440"/>
+          </a:xfrm>
+          <a:prstGeom prst="rect">
+            <a:avLst/>
+          </a:prstGeom>
+          <a:ln w="0">
+            <a:noFill/>
+          </a:ln>
+        </p:spPr>
+      </p:pic>
+      <p:sp>
+        <p:nvSpPr>
+          <p:cNvPr id="303" name=""/>
+          <p:cNvSpPr/>
+          <p:nvPr/>
+        </p:nvSpPr>
+        <p:spPr>
+          <a:xfrm>
+            <a:off x="456840" y="1609560"/>
+            <a:ext cx="4153320" cy="752760"/>
+          </a:xfrm>
+          <a:custGeom>
+            <a:avLst/>
+            <a:gdLst/>
+            <a:ahLst/>
+            <a:rect l="0" t="0" r="r" b="b"/>
+            <a:pathLst>
+              <a:path w="11537" h="2091">
+                <a:moveTo>
+                  <a:pt x="0" y="0"/>
+                </a:moveTo>
+                <a:lnTo>
+                  <a:pt x="11537" y="0"/>
+                </a:lnTo>
+                <a:lnTo>
+                  <a:pt x="11537" y="2091"/>
+                </a:lnTo>
+                <a:lnTo>
+                  <a:pt x="0" y="2091"/>
+                </a:lnTo>
+                <a:lnTo>
+                  <a:pt x="0" y="0"/>
+                </a:lnTo>
+                <a:close/>
+              </a:path>
+            </a:pathLst>
+          </a:custGeom>
+          <a:solidFill>
+            <a:srgbClr val="ffffff"/>
+          </a:solidFill>
+          <a:ln w="0">
+            <a:noFill/>
+          </a:ln>
+        </p:spPr>
+        <p:txBody>
+          <a:bodyPr lIns="0" rIns="0" tIns="0" bIns="0" anchor="t">
+            <a:noAutofit/>
+          </a:bodyPr>
+          <a:p>
+            <a:endParaRPr b="0" lang="en-US" sz="2400" spc="-1" strike="noStrike">
+              <a:solidFill>
+                <a:srgbClr val="000000"/>
+              </a:solidFill>
+              <a:latin typeface="DejaVu Serif"/>
+            </a:endParaRPr>
+          </a:p>
+        </p:txBody>
+      </p:sp>
+      <p:sp>
+        <p:nvSpPr>
+          <p:cNvPr id="304" name=""/>
+          <p:cNvSpPr/>
+          <p:nvPr/>
+        </p:nvSpPr>
+        <p:spPr>
+          <a:xfrm>
+            <a:off x="456840" y="1609560"/>
+            <a:ext cx="4153320" cy="38520"/>
+          </a:xfrm>
+          <a:custGeom>
+            <a:avLst/>
+            <a:gdLst/>
+            <a:ahLst/>
+            <a:rect l="0" t="0" r="r" b="b"/>
+            <a:pathLst>
+              <a:path w="11537" h="107">
+                <a:moveTo>
+                  <a:pt x="0" y="0"/>
+                </a:moveTo>
+                <a:lnTo>
+                  <a:pt x="11537" y="0"/>
+                </a:lnTo>
+                <a:lnTo>
+                  <a:pt x="11537" y="107"/>
+                </a:lnTo>
+                <a:lnTo>
+                  <a:pt x="0" y="107"/>
+                </a:lnTo>
+                <a:lnTo>
+                  <a:pt x="0" y="0"/>
+                </a:lnTo>
+                <a:close/>
+              </a:path>
+            </a:pathLst>
+          </a:custGeom>
+          <a:solidFill>
+            <a:srgbClr val="dd784b"/>
+          </a:solidFill>
+          <a:ln w="0">
+            <a:noFill/>
+          </a:ln>
+        </p:spPr>
+        <p:txBody>
+          <a:bodyPr lIns="0" rIns="0" tIns="0" bIns="0" anchor="t">
+            <a:noAutofit/>
+          </a:bodyPr>
+          <a:p>
+            <a:endParaRPr b="0" lang="en-US" sz="2400" spc="-1" strike="noStrike">
+              <a:solidFill>
+                <a:srgbClr val="000000"/>
+              </a:solidFill>
+              <a:latin typeface="DejaVu Serif"/>
+            </a:endParaRPr>
+          </a:p>
+        </p:txBody>
+      </p:sp>
+      <p:sp>
+        <p:nvSpPr>
+          <p:cNvPr id="305" name=""/>
+          <p:cNvSpPr/>
+          <p:nvPr/>
+        </p:nvSpPr>
+        <p:spPr>
+          <a:xfrm>
+            <a:off x="456840" y="2352600"/>
+            <a:ext cx="4153320" cy="9720"/>
+          </a:xfrm>
+          <a:custGeom>
+            <a:avLst/>
+            <a:gdLst/>
+            <a:ahLst/>
+            <a:rect l="0" t="0" r="r" b="b"/>
+            <a:pathLst>
+              <a:path w="11537" h="27">
+                <a:moveTo>
+                  <a:pt x="0" y="0"/>
+                </a:moveTo>
+                <a:lnTo>
+                  <a:pt x="11537" y="0"/>
+                </a:lnTo>
+                <a:lnTo>
+                  <a:pt x="11537" y="27"/>
+                </a:lnTo>
+                <a:lnTo>
+                  <a:pt x="0" y="27"/>
+                </a:lnTo>
+                <a:lnTo>
+                  <a:pt x="0" y="0"/>
+                </a:lnTo>
+                <a:close/>
+              </a:path>
+            </a:pathLst>
+          </a:custGeom>
+          <a:solidFill>
+            <a:srgbClr val="e5e7eb"/>
+          </a:solidFill>
+          <a:ln w="0">
+            <a:noFill/>
+          </a:ln>
+        </p:spPr>
+        <p:txBody>
+          <a:bodyPr lIns="0" rIns="0" tIns="0" bIns="0" anchor="t">
+            <a:noAutofit/>
+          </a:bodyPr>
+          <a:p>
+            <a:endParaRPr b="0" lang="en-US" sz="2400" spc="-1" strike="noStrike">
+              <a:solidFill>
+                <a:srgbClr val="000000"/>
+              </a:solidFill>
+              <a:latin typeface="DejaVu Serif"/>
+            </a:endParaRPr>
+          </a:p>
+        </p:txBody>
+      </p:sp>
+      <p:sp>
+        <p:nvSpPr>
+          <p:cNvPr id="306" name=""/>
+          <p:cNvSpPr/>
+          <p:nvPr/>
+        </p:nvSpPr>
+        <p:spPr>
+          <a:xfrm>
+            <a:off x="4600440" y="1609560"/>
+            <a:ext cx="9720" cy="752760"/>
+          </a:xfrm>
+          <a:custGeom>
+            <a:avLst/>
+            <a:gdLst/>
+            <a:ahLst/>
+            <a:rect l="0" t="0" r="r" b="b"/>
+            <a:pathLst>
+              <a:path w="27" h="2091">
+                <a:moveTo>
+                  <a:pt x="0" y="106"/>
+                </a:moveTo>
+                <a:lnTo>
+                  <a:pt x="0" y="2091"/>
+                </a:lnTo>
+                <a:lnTo>
+                  <a:pt x="27" y="2091"/>
+                </a:lnTo>
+                <a:lnTo>
+                  <a:pt x="27" y="0"/>
+                </a:lnTo>
+                <a:lnTo>
+                  <a:pt x="0" y="106"/>
+                </a:lnTo>
+                <a:close/>
+              </a:path>
+            </a:pathLst>
+          </a:custGeom>
+          <a:solidFill>
+            <a:srgbClr val="e5e7eb"/>
+          </a:solidFill>
+          <a:ln w="0">
+            <a:noFill/>
+          </a:ln>
+        </p:spPr>
+        <p:txBody>
+          <a:bodyPr lIns="0" rIns="0" tIns="0" bIns="0" anchor="t">
+            <a:noAutofit/>
+          </a:bodyPr>
+          <a:p>
+            <a:endParaRPr b="0" lang="en-US" sz="2400" spc="-1" strike="noStrike">
+              <a:solidFill>
+                <a:srgbClr val="000000"/>
+              </a:solidFill>
+              <a:latin typeface="DejaVu Serif"/>
+            </a:endParaRPr>
+          </a:p>
+        </p:txBody>
+      </p:sp>
+      <p:sp>
+        <p:nvSpPr>
+          <p:cNvPr id="307" name=""/>
+          <p:cNvSpPr/>
+          <p:nvPr/>
+        </p:nvSpPr>
+        <p:spPr>
+          <a:xfrm>
+            <a:off x="456840" y="1609560"/>
+            <a:ext cx="10080" cy="752760"/>
+          </a:xfrm>
+          <a:custGeom>
+            <a:avLst/>
+            <a:gdLst/>
+            <a:ahLst/>
+            <a:rect l="0" t="0" r="r" b="b"/>
+            <a:pathLst>
+              <a:path w="28" h="2091">
+                <a:moveTo>
+                  <a:pt x="0" y="0"/>
+                </a:moveTo>
+                <a:lnTo>
+                  <a:pt x="0" y="2091"/>
+                </a:lnTo>
+                <a:lnTo>
+                  <a:pt x="28" y="2091"/>
+                </a:lnTo>
+                <a:lnTo>
+                  <a:pt x="28" y="106"/>
+                </a:lnTo>
+                <a:lnTo>
+                  <a:pt x="0" y="0"/>
+                </a:lnTo>
+                <a:close/>
+              </a:path>
+            </a:pathLst>
+          </a:custGeom>
+          <a:solidFill>
+            <a:srgbClr val="e5e7eb"/>
+          </a:solidFill>
+          <a:ln w="0">
+            <a:noFill/>
+          </a:ln>
+        </p:spPr>
+        <p:txBody>
+          <a:bodyPr lIns="0" rIns="0" tIns="0" bIns="0" anchor="t">
+            <a:noAutofit/>
+          </a:bodyPr>
+          <a:p>
+            <a:endParaRPr b="0" lang="en-US" sz="2400" spc="-1" strike="noStrike">
+              <a:solidFill>
+                <a:srgbClr val="000000"/>
+              </a:solidFill>
+              <a:latin typeface="DejaVu Serif"/>
+            </a:endParaRPr>
+          </a:p>
+        </p:txBody>
+      </p:sp>
+      <p:sp>
+        <p:nvSpPr>
+          <p:cNvPr id="308" name=""/>
           <p:cNvSpPr txBox="1"/>
           <p:nvPr/>
         </p:nvSpPr>
@@ -18966,7 +22136,7 @@
       </p:sp>
       <p:sp>
         <p:nvSpPr>
-          <p:cNvPr id="258" name=""/>
+          <p:cNvPr id="309" name=""/>
           <p:cNvSpPr txBox="1"/>
           <p:nvPr/>
         </p:nvSpPr>
@@ -19009,7 +22179,7 @@
       </p:sp>
       <p:sp>
         <p:nvSpPr>
-          <p:cNvPr id="259" name=""/>
+          <p:cNvPr id="310" name=""/>
           <p:cNvSpPr/>
           <p:nvPr/>
         </p:nvSpPr>
@@ -19067,7 +22237,7 @@
       </p:sp>
       <p:sp>
         <p:nvSpPr>
-          <p:cNvPr id="260" name=""/>
+          <p:cNvPr id="311" name=""/>
           <p:cNvSpPr/>
           <p:nvPr/>
         </p:nvSpPr>
@@ -19125,7 +22295,7 @@
       </p:sp>
       <p:sp>
         <p:nvSpPr>
-          <p:cNvPr id="261" name=""/>
+          <p:cNvPr id="312" name=""/>
           <p:cNvSpPr/>
           <p:nvPr/>
         </p:nvSpPr>
@@ -19183,7 +22353,7 @@
       </p:sp>
       <p:sp>
         <p:nvSpPr>
-          <p:cNvPr id="262" name=""/>
+          <p:cNvPr id="313" name=""/>
           <p:cNvSpPr/>
           <p:nvPr/>
         </p:nvSpPr>
@@ -19241,7 +22411,7 @@
       </p:sp>
       <p:sp>
         <p:nvSpPr>
-          <p:cNvPr id="263" name=""/>
+          <p:cNvPr id="314" name=""/>
           <p:cNvSpPr/>
           <p:nvPr/>
         </p:nvSpPr>
@@ -19299,7 +22469,7 @@
       </p:sp>
       <p:sp>
         <p:nvSpPr>
-          <p:cNvPr id="264" name=""/>
+          <p:cNvPr id="315" name=""/>
           <p:cNvSpPr txBox="1"/>
           <p:nvPr/>
         </p:nvSpPr>
@@ -19342,7 +22512,7 @@
       </p:sp>
       <p:sp>
         <p:nvSpPr>
-          <p:cNvPr id="265" name=""/>
+          <p:cNvPr id="316" name=""/>
           <p:cNvSpPr txBox="1"/>
           <p:nvPr/>
         </p:nvSpPr>
@@ -19385,7 +22555,7 @@
       </p:sp>
       <p:sp>
         <p:nvSpPr>
-          <p:cNvPr id="266" name=""/>
+          <p:cNvPr id="317" name=""/>
           <p:cNvSpPr/>
           <p:nvPr/>
         </p:nvSpPr>
@@ -19443,7 +22613,7 @@
       </p:sp>
       <p:sp>
         <p:nvSpPr>
-          <p:cNvPr id="267" name=""/>
+          <p:cNvPr id="318" name=""/>
           <p:cNvSpPr/>
           <p:nvPr/>
         </p:nvSpPr>
@@ -19501,7 +22671,7 @@
       </p:sp>
       <p:sp>
         <p:nvSpPr>
-          <p:cNvPr id="268" name=""/>
+          <p:cNvPr id="319" name=""/>
           <p:cNvSpPr/>
           <p:nvPr/>
         </p:nvSpPr>
@@ -19559,7 +22729,7 @@
       </p:sp>
       <p:sp>
         <p:nvSpPr>
-          <p:cNvPr id="269" name=""/>
+          <p:cNvPr id="320" name=""/>
           <p:cNvSpPr/>
           <p:nvPr/>
         </p:nvSpPr>
@@ -19617,7 +22787,7 @@
       </p:sp>
       <p:sp>
         <p:nvSpPr>
-          <p:cNvPr id="270" name=""/>
+          <p:cNvPr id="321" name=""/>
           <p:cNvSpPr/>
           <p:nvPr/>
         </p:nvSpPr>
@@ -19675,7 +22845,7 @@
       </p:sp>
       <p:sp>
         <p:nvSpPr>
-          <p:cNvPr id="271" name=""/>
+          <p:cNvPr id="322" name=""/>
           <p:cNvSpPr txBox="1"/>
           <p:nvPr/>
         </p:nvSpPr>
@@ -19718,7 +22888,7 @@
       </p:sp>
       <p:sp>
         <p:nvSpPr>
-          <p:cNvPr id="272" name=""/>
+          <p:cNvPr id="323" name=""/>
           <p:cNvSpPr txBox="1"/>
           <p:nvPr/>
         </p:nvSpPr>
@@ -19761,7 +22931,7 @@
       </p:sp>
       <p:sp>
         <p:nvSpPr>
-          <p:cNvPr id="273" name=""/>
+          <p:cNvPr id="324" name=""/>
           <p:cNvSpPr/>
           <p:nvPr/>
         </p:nvSpPr>
@@ -19819,7 +22989,7 @@
       </p:sp>
       <p:sp>
         <p:nvSpPr>
-          <p:cNvPr id="274" name=""/>
+          <p:cNvPr id="325" name=""/>
           <p:cNvSpPr/>
           <p:nvPr/>
         </p:nvSpPr>
@@ -19877,7 +23047,7 @@
       </p:sp>
       <p:sp>
         <p:nvSpPr>
-          <p:cNvPr id="275" name=""/>
+          <p:cNvPr id="326" name=""/>
           <p:cNvSpPr/>
           <p:nvPr/>
         </p:nvSpPr>
@@ -19935,7 +23105,7 @@
       </p:sp>
       <p:sp>
         <p:nvSpPr>
-          <p:cNvPr id="276" name=""/>
+          <p:cNvPr id="327" name=""/>
           <p:cNvSpPr/>
           <p:nvPr/>
         </p:nvSpPr>
@@ -19993,7 +23163,7 @@
       </p:sp>
       <p:sp>
         <p:nvSpPr>
-          <p:cNvPr id="277" name=""/>
+          <p:cNvPr id="328" name=""/>
           <p:cNvSpPr/>
           <p:nvPr/>
         </p:nvSpPr>
@@ -20051,7 +23221,7 @@
       </p:sp>
       <p:sp>
         <p:nvSpPr>
-          <p:cNvPr id="278" name=""/>
+          <p:cNvPr id="329" name=""/>
           <p:cNvSpPr txBox="1"/>
           <p:nvPr/>
         </p:nvSpPr>
@@ -20094,7 +23264,7 @@
       </p:sp>
       <p:sp>
         <p:nvSpPr>
-          <p:cNvPr id="279" name=""/>
+          <p:cNvPr id="330" name=""/>
           <p:cNvSpPr txBox="1"/>
           <p:nvPr/>
         </p:nvSpPr>
@@ -20137,7 +23307,7 @@
       </p:sp>
       <p:sp>
         <p:nvSpPr>
-          <p:cNvPr id="280" name=""/>
+          <p:cNvPr id="331" name=""/>
           <p:cNvSpPr/>
           <p:nvPr/>
         </p:nvSpPr>
@@ -20195,7 +23365,7 @@
       </p:sp>
       <p:sp>
         <p:nvSpPr>
-          <p:cNvPr id="281" name=""/>
+          <p:cNvPr id="332" name=""/>
           <p:cNvSpPr/>
           <p:nvPr/>
         </p:nvSpPr>
@@ -20253,7 +23423,7 @@
       </p:sp>
       <p:sp>
         <p:nvSpPr>
-          <p:cNvPr id="282" name=""/>
+          <p:cNvPr id="333" name=""/>
           <p:cNvSpPr/>
           <p:nvPr/>
         </p:nvSpPr>
@@ -20311,7 +23481,7 @@
       </p:sp>
       <p:sp>
         <p:nvSpPr>
-          <p:cNvPr id="283" name=""/>
+          <p:cNvPr id="334" name=""/>
           <p:cNvSpPr/>
           <p:nvPr/>
         </p:nvSpPr>
@@ -20369,7 +23539,7 @@
       </p:sp>
       <p:sp>
         <p:nvSpPr>
-          <p:cNvPr id="284" name=""/>
+          <p:cNvPr id="335" name=""/>
           <p:cNvSpPr/>
           <p:nvPr/>
         </p:nvSpPr>
@@ -20427,7 +23597,7 @@
       </p:sp>
       <p:sp>
         <p:nvSpPr>
-          <p:cNvPr id="285" name=""/>
+          <p:cNvPr id="336" name=""/>
           <p:cNvSpPr txBox="1"/>
           <p:nvPr/>
         </p:nvSpPr>
@@ -20470,7 +23640,7 @@
       </p:sp>
       <p:sp>
         <p:nvSpPr>
-          <p:cNvPr id="286" name=""/>
+          <p:cNvPr id="337" name=""/>
           <p:cNvSpPr txBox="1"/>
           <p:nvPr/>
         </p:nvSpPr>
@@ -20513,7 +23683,7 @@
       </p:sp>
       <p:sp>
         <p:nvSpPr>
-          <p:cNvPr id="287" name=""/>
+          <p:cNvPr id="338" name=""/>
           <p:cNvSpPr txBox="1"/>
           <p:nvPr/>
         </p:nvSpPr>

</xml_diff>